<commit_message>
Refine Spanish prose; add slide-5 schematic and sabatina backup annex
- manifest.py: refined prose kept within the 12-slide structure; restores
  case facts from the approved draft (no added exam findings), removes
  unsupported claims (necrosis prevention, 'contraindicación formal').
- Slide 5 now uses 'definition' with the AI-generated obstruction schematic
  (labelled as illustrative, source credited); three mechanisms kept as key points.
- PDF: refined script for all 12 slides, sabatina backup annex (ultrasound
  differential table from Caso_09_UCP.pptx slide 11, opening line for Relator 1
  derived from slide 4 - not a verbatim quote), source provenance.
- Rebuilt deck: lint PASS, 12 slides, contrast 0 violations.

Co-authored-by: arena-agent <297053741+arena-agent@users.noreply.github.com>
</commit_message>
<xml_diff>
--- a/entregas-es/pancreatitis-biliar/Pancreatitis_biliar_12_diapositivas_es.pptx
+++ b/entregas-es/pancreatitis-biliar/Pancreatitis_biliar_12_diapositivas_es.pptx
@@ -3921,7 +3921,7 @@
                 </a:solidFill>
                 <a:latin typeface="Montserrat"/>
               </a:rPr>
-              <a:t>Ringer lactato 250–500 mL/h inicial, dirigido por metas (PAM, hematocrito, diuresis &gt; 0,5 mL/kg/h). Menos acidosis hiperclorémica que el SF 0,9 %.</a:t>
+              <a:t>Ringer lactato 250–500 mL/h inicial, dirigido por metas (PAM, hematocrito, diuresis &gt; 0,5 mL/kg/h). Menor acidosis hiperclorémica que con SF 0,9 %.</a:t>
             </a:r>
           </a:p>
         </p:txBody>
@@ -4331,7 +4331,7 @@
                 </a:solidFill>
                 <a:latin typeface="Montserrat"/>
               </a:rPr>
-              <a:t>Dipirona magnésica IV 1–2 g c/6–8 h (base); tramadol IV 50–100 mg c/8 h (rescate). Evitar morfina: induce espasmo del esfínter de Oddi.</a:t>
+              <a:t>Dipirona magnésica IV 1–2 g c/6–8 h como base; tramadol IV 50–100 mg c/8 h de rescate. Evitar morfina: induce espasmo del esfínter de Oddi.</a:t>
             </a:r>
           </a:p>
         </p:txBody>
@@ -5169,7 +5169,7 @@
                 </a:solidFill>
                 <a:latin typeface="Montserrat"/>
               </a:rPr>
-              <a:t>Al remitir la clínica aguda (PONCHO). Evita la recidiva biliar: 30 % a 90 días sin cirugía.</a:t>
+              <a:t>Tras remitir la clínica aguda (PONCHO). Previene la recidiva biliar: 30 % a 90 días sin cirugía.</a:t>
             </a:r>
           </a:p>
         </p:txBody>
@@ -8003,7 +8003,7 @@
                 </a:solidFill>
                 <a:latin typeface="Montserrat"/>
               </a:rPr>
-              <a:t>Paciente femenina de 38 años con enfermedad vesicular de larga evolución y cólicos biliares a repetición. Cuadro actual: dolor abdominal súbito, constante y de intensidad severa en epigastrio y mesogastrio.</a:t>
+              <a:t>Paciente femenina de 38 años con enfermedad vesicular de larga evolución y cólicos biliares a repetición. Ingresa con dolor abdominal súbito, constante y de intensidad severa en epigastrio y mesogastrio.</a:t>
             </a:r>
           </a:p>
         </p:txBody>
@@ -8140,7 +8140,7 @@
                 </a:solidFill>
                 <a:latin typeface="Montserrat"/>
               </a:rPr>
-              <a:t>• Ruidos hidroaéreos marcadamente disminuidos (íleo paralítico reflejo)</a:t>
+              <a:t>• Ruidos hidroaéreos marcadamente disminuidos: íleo paralítico reflejo</a:t>
             </a:r>
           </a:p>
         </p:txBody>
@@ -8255,7 +8255,7 @@
                 </a:solidFill>
                 <a:latin typeface="Montserrat"/>
               </a:rPr>
-              <a:t>Antecedente litiásico, dolor epigástrico súbito y severo, e íleo reflejo orientan a una pancreatitis aguda de origen biliar.</a:t>
+              <a:t>La enfermedad vesicular previa, el dolor epigástrico súbito y severo y el íleo reflejo orientan de inmediato a pancreatitis aguda de origen biliar.</a:t>
             </a:r>
           </a:p>
         </p:txBody>
@@ -8483,7 +8483,7 @@
                 </a:solidFill>
                 <a:latin typeface="Montserrat"/>
               </a:rPr>
-              <a:t>La correlación de antecedente litiásico, dolor típico y lipasa elevada cierra la etiología biliar.</a:t>
+              <a:t>El antecedente litiásico, el dolor típico y la lipasa elevada cierran la etiología biliar de forma categórica.</a:t>
             </a:r>
           </a:p>
         </p:txBody>
@@ -8585,7 +8585,7 @@
                 </a:solidFill>
                 <a:latin typeface="Montserrat"/>
               </a:rPr>
-              <a:t>Criterios de Atlanta: cumple 3 de 3 (basta 2)</a:t>
+              <a:t>Criterios de Atlanta: 3 de 3 cumplidos (se requieren 2)</a:t>
             </a:r>
           </a:p>
         </p:txBody>
@@ -8962,7 +8962,7 @@
                 </a:solidFill>
                 <a:latin typeface="Montserrat"/>
               </a:rPr>
-              <a:t>Dolor abdominal agudo típico en hemiabdomen superior con irradiación posterior.</a:t>
+              <a:t>Dolor abdominal agudo típico en hemiabdomen superior, con irradiación posterior.</a:t>
             </a:r>
           </a:p>
         </p:txBody>
@@ -9167,7 +9167,7 @@
                 </a:solidFill>
                 <a:latin typeface="Montserrat"/>
               </a:rPr>
-              <a:t>Lipasa sérica &gt; 3 veces el límite superior normal: elevación patológica marcada.</a:t>
+              <a:t>Elevación patológica marcada de lipasa sérica: más de 3 veces el límite superior normal.</a:t>
             </a:r>
           </a:p>
         </p:txBody>
@@ -9414,7 +9414,7 @@
                 </a:solidFill>
                 <a:latin typeface="Montserrat"/>
               </a:rPr>
-              <a:t>Dx definitivo: pancreatitis aguda edematosa intersticial litiásica. Diferenciales: úlcera perforada, colecistitis, obstrucción.</a:t>
+              <a:t>Dx definitivo: pancreatitis edematosa intersticial litiásica. Diferenciales: úlcera perforada (descartada), colecistitis, obstrucción.</a:t>
             </a:r>
           </a:p>
         </p:txBody>
@@ -9701,8 +9701,8 @@
         </p:nvSpPr>
         <p:spPr>
           <a:xfrm>
-            <a:off x="594360" y="1508760"/>
-            <a:ext cx="3444240" cy="4206240"/>
+            <a:off x="594360" y="1417320"/>
+            <a:ext cx="6949440" cy="1325880"/>
           </a:xfrm>
           <a:prstGeom prst="roundRect">
             <a:avLst>
@@ -9743,14 +9743,58 @@
       </p:sp>
       <p:sp>
         <p:nvSpPr>
-          <p:cNvPr id="9" name="Rounded Rectangle 8"/>
+          <p:cNvPr id="9" name="Rectangle 8"/>
           <p:cNvSpPr/>
           <p:nvPr/>
         </p:nvSpPr>
         <p:spPr>
           <a:xfrm>
-            <a:off x="758952" y="1673351"/>
-            <a:ext cx="731520" cy="256032"/>
+            <a:off x="594360" y="1417320"/>
+            <a:ext cx="82296" cy="1325880"/>
+          </a:xfrm>
+          <a:prstGeom prst="rect">
+            <a:avLst/>
+          </a:prstGeom>
+          <a:solidFill>
+            <a:srgbClr val="3854CC"/>
+          </a:solidFill>
+          <a:ln>
+            <a:noFill/>
+          </a:ln>
+          <a:effectLst/>
+        </p:spPr>
+        <p:style>
+          <a:lnRef idx="1">
+            <a:schemeClr val="accent1"/>
+          </a:lnRef>
+          <a:fillRef idx="3">
+            <a:schemeClr val="accent1"/>
+          </a:fillRef>
+          <a:effectRef idx="2">
+            <a:schemeClr val="accent1"/>
+          </a:effectRef>
+          <a:fontRef idx="minor">
+            <a:schemeClr val="lt1"/>
+          </a:fontRef>
+        </p:style>
+        <p:txBody>
+          <a:bodyPr rtlCol="0" anchor="ctr"/>
+          <a:lstStyle/>
+          <a:p>
+            <a:pPr algn="ctr"/>
+          </a:p>
+        </p:txBody>
+      </p:sp>
+      <p:sp>
+        <p:nvSpPr>
+          <p:cNvPr id="10" name="Rounded Rectangle 9"/>
+          <p:cNvSpPr/>
+          <p:nvPr/>
+        </p:nvSpPr>
+        <p:spPr>
+          <a:xfrm>
+            <a:off x="868680" y="1536192"/>
+            <a:ext cx="1463040" cy="219456"/>
           </a:xfrm>
           <a:prstGeom prst="roundRect">
             <a:avLst>
@@ -9789,14 +9833,14 @@
       </p:sp>
       <p:sp>
         <p:nvSpPr>
-          <p:cNvPr id="10" name="TextBox 9"/>
+          <p:cNvPr id="11" name="TextBox 10"/>
           <p:cNvSpPr txBox="1"/>
           <p:nvPr/>
         </p:nvSpPr>
         <p:spPr>
           <a:xfrm>
-            <a:off x="758952" y="1673351"/>
-            <a:ext cx="731520" cy="256032"/>
+            <a:off x="868680" y="1536192"/>
+            <a:ext cx="1463040" cy="219456"/>
           </a:xfrm>
           <a:prstGeom prst="rect">
             <a:avLst/>
@@ -9824,21 +9868,245 @@
                 </a:solidFill>
                 <a:latin typeface="Montserrat"/>
               </a:rPr>
-              <a:t>1</a:t>
-            </a:r>
-          </a:p>
-        </p:txBody>
-      </p:sp>
-      <p:sp>
-        <p:nvSpPr>
-          <p:cNvPr id="11" name="TextBox 10"/>
+              <a:t>ENUNCIADO CENTRAL</a:t>
+            </a:r>
+          </a:p>
+        </p:txBody>
+      </p:sp>
+      <p:sp>
+        <p:nvSpPr>
+          <p:cNvPr id="12" name="TextBox 11"/>
           <p:cNvSpPr txBox="1"/>
           <p:nvPr/>
         </p:nvSpPr>
         <p:spPr>
           <a:xfrm>
-            <a:off x="777240" y="2039112"/>
-            <a:ext cx="3078480" cy="3520439"/>
+            <a:off x="868680" y="1810512"/>
+            <a:ext cx="6492240" cy="868680"/>
+          </a:xfrm>
+          <a:prstGeom prst="rect">
+            <a:avLst/>
+          </a:prstGeom>
+          <a:noFill/>
+        </p:spPr>
+        <p:txBody>
+          <a:bodyPr wrap="square" anchor="t" lIns="0" rIns="0" tIns="0" bIns="0">
+            <a:spAutoFit/>
+          </a:bodyPr>
+          <a:lstStyle/>
+          <a:p>
+            <a:pPr algn="l">
+              <a:lnSpc>
+                <a:spcPct val="110000"/>
+              </a:lnSpc>
+              <a:spcAft>
+                <a:spcPts val="300"/>
+              </a:spcAft>
+            </a:pPr>
+            <a:r>
+              <a:rPr sz="1550" b="1" i="0">
+                <a:solidFill>
+                  <a:srgbClr val="3854CC"/>
+                </a:solidFill>
+                <a:latin typeface="Montserrat"/>
+              </a:rPr>
+              <a:t>Microcálculos migran desde la vesícula, pasan por el colédoco y se impactan en la ampolla de Vater, bloqueando el flujo pancreático.</a:t>
+            </a:r>
+          </a:p>
+        </p:txBody>
+      </p:sp>
+      <p:sp>
+        <p:nvSpPr>
+          <p:cNvPr id="13" name="Rounded Rectangle 12"/>
+          <p:cNvSpPr/>
+          <p:nvPr/>
+        </p:nvSpPr>
+        <p:spPr>
+          <a:xfrm>
+            <a:off x="594360" y="2880360"/>
+            <a:ext cx="6949440" cy="777240"/>
+          </a:xfrm>
+          <a:prstGeom prst="roundRect">
+            <a:avLst>
+              <a:gd name="adj" fmla="val 4000"/>
+            </a:avLst>
+          </a:prstGeom>
+          <a:solidFill>
+            <a:srgbClr val="EEF0FF"/>
+          </a:solidFill>
+          <a:ln w="5080">
+            <a:solidFill>
+              <a:srgbClr val="D9DDF2"/>
+            </a:solidFill>
+          </a:ln>
+          <a:effectLst/>
+        </p:spPr>
+        <p:style>
+          <a:lnRef idx="1">
+            <a:schemeClr val="accent1"/>
+          </a:lnRef>
+          <a:fillRef idx="3">
+            <a:schemeClr val="accent1"/>
+          </a:fillRef>
+          <a:effectRef idx="2">
+            <a:schemeClr val="accent1"/>
+          </a:effectRef>
+          <a:fontRef idx="minor">
+            <a:schemeClr val="lt1"/>
+          </a:fontRef>
+        </p:style>
+        <p:txBody>
+          <a:bodyPr rtlCol="0" anchor="ctr"/>
+          <a:lstStyle/>
+          <a:p>
+            <a:pPr algn="ctr"/>
+          </a:p>
+        </p:txBody>
+      </p:sp>
+      <p:sp>
+        <p:nvSpPr>
+          <p:cNvPr id="14" name="TextBox 13"/>
+          <p:cNvSpPr txBox="1"/>
+          <p:nvPr/>
+        </p:nvSpPr>
+        <p:spPr>
+          <a:xfrm>
+            <a:off x="777240" y="2990088"/>
+            <a:ext cx="6583679" cy="594360"/>
+          </a:xfrm>
+          <a:prstGeom prst="rect">
+            <a:avLst/>
+          </a:prstGeom>
+          <a:noFill/>
+        </p:spPr>
+        <p:txBody>
+          <a:bodyPr wrap="square" anchor="t" lIns="0" rIns="0" tIns="0" bIns="0">
+            <a:spAutoFit/>
+          </a:bodyPr>
+          <a:lstStyle/>
+          <a:p>
+            <a:pPr algn="l">
+              <a:lnSpc>
+                <a:spcPct val="115000"/>
+              </a:lnSpc>
+              <a:spcAft>
+                <a:spcPts val="300"/>
+              </a:spcAft>
+            </a:pPr>
+            <a:r>
+              <a:rPr sz="1200" b="0" i="0">
+                <a:solidFill>
+                  <a:srgbClr val="2B2C4A"/>
+                </a:solidFill>
+                <a:latin typeface="Montserrat"/>
+              </a:rPr>
+              <a:t>La obstrucción transitoria eleva la presión ductal y el jugo pancreático queda estancado.</a:t>
+            </a:r>
+          </a:p>
+        </p:txBody>
+      </p:sp>
+      <p:sp>
+        <p:nvSpPr>
+          <p:cNvPr id="15" name="Rounded Rectangle 14"/>
+          <p:cNvSpPr/>
+          <p:nvPr/>
+        </p:nvSpPr>
+        <p:spPr>
+          <a:xfrm>
+            <a:off x="594360" y="3794760"/>
+            <a:ext cx="3374136" cy="2240279"/>
+          </a:xfrm>
+          <a:prstGeom prst="roundRect">
+            <a:avLst>
+              <a:gd name="adj" fmla="val 4000"/>
+            </a:avLst>
+          </a:prstGeom>
+          <a:solidFill>
+            <a:srgbClr val="FFFFFF"/>
+          </a:solidFill>
+          <a:ln w="7620">
+            <a:solidFill>
+              <a:srgbClr val="D9DDF2"/>
+            </a:solidFill>
+          </a:ln>
+          <a:effectLst/>
+        </p:spPr>
+        <p:style>
+          <a:lnRef idx="1">
+            <a:schemeClr val="accent1"/>
+          </a:lnRef>
+          <a:fillRef idx="3">
+            <a:schemeClr val="accent1"/>
+          </a:fillRef>
+          <a:effectRef idx="2">
+            <a:schemeClr val="accent1"/>
+          </a:effectRef>
+          <a:fontRef idx="minor">
+            <a:schemeClr val="lt1"/>
+          </a:fontRef>
+        </p:style>
+        <p:txBody>
+          <a:bodyPr rtlCol="0" anchor="ctr"/>
+          <a:lstStyle/>
+          <a:p>
+            <a:pPr algn="ctr"/>
+          </a:p>
+        </p:txBody>
+      </p:sp>
+      <p:sp>
+        <p:nvSpPr>
+          <p:cNvPr id="16" name="Rectangle 15"/>
+          <p:cNvSpPr/>
+          <p:nvPr/>
+        </p:nvSpPr>
+        <p:spPr>
+          <a:xfrm>
+            <a:off x="594360" y="3794760"/>
+            <a:ext cx="3374136" cy="45720"/>
+          </a:xfrm>
+          <a:prstGeom prst="rect">
+            <a:avLst/>
+          </a:prstGeom>
+          <a:solidFill>
+            <a:srgbClr val="D92A2B"/>
+          </a:solidFill>
+          <a:ln>
+            <a:noFill/>
+          </a:ln>
+          <a:effectLst/>
+        </p:spPr>
+        <p:style>
+          <a:lnRef idx="1">
+            <a:schemeClr val="accent1"/>
+          </a:lnRef>
+          <a:fillRef idx="3">
+            <a:schemeClr val="accent1"/>
+          </a:fillRef>
+          <a:effectRef idx="2">
+            <a:schemeClr val="accent1"/>
+          </a:effectRef>
+          <a:fontRef idx="minor">
+            <a:schemeClr val="lt1"/>
+          </a:fontRef>
+        </p:style>
+        <p:txBody>
+          <a:bodyPr rtlCol="0" anchor="ctr"/>
+          <a:lstStyle/>
+          <a:p>
+            <a:pPr algn="ctr"/>
+          </a:p>
+        </p:txBody>
+      </p:sp>
+      <p:sp>
+        <p:nvSpPr>
+          <p:cNvPr id="17" name="TextBox 16"/>
+          <p:cNvSpPr txBox="1"/>
+          <p:nvPr/>
+        </p:nvSpPr>
+        <p:spPr>
+          <a:xfrm>
+            <a:off x="777240" y="3959352"/>
+            <a:ext cx="3008376" cy="1965959"/>
           </a:xfrm>
           <a:prstGeom prst="rect">
             <a:avLst/>
@@ -9859,17 +10127,17 @@
                 <a:spcPts val="0"/>
               </a:spcBef>
               <a:spcAft>
-                <a:spcPts val="600"/>
+                <a:spcPts val="400"/>
               </a:spcAft>
             </a:pPr>
             <a:r>
-              <a:rPr sz="1350" b="1" i="0">
+              <a:rPr sz="1250" b="1" i="0">
                 <a:solidFill>
                   <a:srgbClr val="3854CC"/>
                 </a:solidFill>
                 <a:latin typeface="Montserrat"/>
               </a:rPr>
-              <a:t>Génesis</a:t>
+              <a:t>Canal común (Opie)</a:t>
             </a:r>
           </a:p>
           <a:p>
@@ -9891,23 +10159,71 @@
                 </a:solidFill>
                 <a:latin typeface="Montserrat"/>
               </a:rPr>
-              <a:t>Migración de microcálculos desde la vesícula biliar a través del conducto cístico.</a:t>
-            </a:r>
-          </a:p>
-        </p:txBody>
-      </p:sp>
-      <p:sp>
-        <p:nvSpPr>
-          <p:cNvPr id="12" name="Right Arrow 11"/>
+              <a:t>Impactación litiásica transitoria en la ampolla de Vater y el esfínter de Oddi.</a:t>
+            </a:r>
+          </a:p>
+        </p:txBody>
+      </p:sp>
+      <p:sp>
+        <p:nvSpPr>
+          <p:cNvPr id="18" name="Rounded Rectangle 17"/>
           <p:cNvSpPr/>
           <p:nvPr/>
         </p:nvSpPr>
         <p:spPr>
           <a:xfrm>
-            <a:off x="4084320" y="3502151"/>
-            <a:ext cx="228599" cy="219456"/>
-          </a:xfrm>
-          <a:prstGeom prst="rightArrow">
+            <a:off x="4169664" y="3794760"/>
+            <a:ext cx="3374136" cy="2240279"/>
+          </a:xfrm>
+          <a:prstGeom prst="roundRect">
+            <a:avLst>
+              <a:gd name="adj" fmla="val 4000"/>
+            </a:avLst>
+          </a:prstGeom>
+          <a:solidFill>
+            <a:srgbClr val="FFFFFF"/>
+          </a:solidFill>
+          <a:ln w="7620">
+            <a:solidFill>
+              <a:srgbClr val="D9DDF2"/>
+            </a:solidFill>
+          </a:ln>
+          <a:effectLst/>
+        </p:spPr>
+        <p:style>
+          <a:lnRef idx="1">
+            <a:schemeClr val="accent1"/>
+          </a:lnRef>
+          <a:fillRef idx="3">
+            <a:schemeClr val="accent1"/>
+          </a:fillRef>
+          <a:effectRef idx="2">
+            <a:schemeClr val="accent1"/>
+          </a:effectRef>
+          <a:fontRef idx="minor">
+            <a:schemeClr val="lt1"/>
+          </a:fontRef>
+        </p:style>
+        <p:txBody>
+          <a:bodyPr rtlCol="0" anchor="ctr"/>
+          <a:lstStyle/>
+          <a:p>
+            <a:pPr algn="ctr"/>
+          </a:p>
+        </p:txBody>
+      </p:sp>
+      <p:sp>
+        <p:nvSpPr>
+          <p:cNvPr id="19" name="Rectangle 18"/>
+          <p:cNvSpPr/>
+          <p:nvPr/>
+        </p:nvSpPr>
+        <p:spPr>
+          <a:xfrm>
+            <a:off x="4169664" y="3794760"/>
+            <a:ext cx="3374136" cy="45720"/>
+          </a:xfrm>
+          <a:prstGeom prst="rect">
             <a:avLst/>
           </a:prstGeom>
           <a:solidFill>
@@ -9942,150 +10258,14 @@
       </p:sp>
       <p:sp>
         <p:nvSpPr>
-          <p:cNvPr id="13" name="Rounded Rectangle 12"/>
-          <p:cNvSpPr/>
-          <p:nvPr/>
-        </p:nvSpPr>
-        <p:spPr>
-          <a:xfrm>
-            <a:off x="4358640" y="1508760"/>
-            <a:ext cx="3444240" cy="4206240"/>
-          </a:xfrm>
-          <a:prstGeom prst="roundRect">
-            <a:avLst>
-              <a:gd name="adj" fmla="val 4000"/>
-            </a:avLst>
-          </a:prstGeom>
-          <a:solidFill>
-            <a:srgbClr val="3854CC"/>
-          </a:solidFill>
-          <a:ln w="12700">
-            <a:solidFill>
-              <a:srgbClr val="D92A2B"/>
-            </a:solidFill>
-          </a:ln>
-          <a:effectLst/>
-        </p:spPr>
-        <p:style>
-          <a:lnRef idx="1">
-            <a:schemeClr val="accent1"/>
-          </a:lnRef>
-          <a:fillRef idx="3">
-            <a:schemeClr val="accent1"/>
-          </a:fillRef>
-          <a:effectRef idx="2">
-            <a:schemeClr val="accent1"/>
-          </a:effectRef>
-          <a:fontRef idx="minor">
-            <a:schemeClr val="lt1"/>
-          </a:fontRef>
-        </p:style>
-        <p:txBody>
-          <a:bodyPr rtlCol="0" anchor="ctr"/>
-          <a:lstStyle/>
-          <a:p>
-            <a:pPr algn="ctr"/>
-          </a:p>
-        </p:txBody>
-      </p:sp>
-      <p:sp>
-        <p:nvSpPr>
-          <p:cNvPr id="14" name="Rounded Rectangle 13"/>
-          <p:cNvSpPr/>
-          <p:nvPr/>
-        </p:nvSpPr>
-        <p:spPr>
-          <a:xfrm>
-            <a:off x="4523232" y="1673351"/>
-            <a:ext cx="731520" cy="256032"/>
-          </a:xfrm>
-          <a:prstGeom prst="roundRect">
-            <a:avLst>
-              <a:gd name="adj" fmla="val 8000"/>
-            </a:avLst>
-          </a:prstGeom>
-          <a:solidFill>
-            <a:srgbClr val="D92A2B"/>
-          </a:solidFill>
-          <a:ln>
-            <a:noFill/>
-          </a:ln>
-          <a:effectLst/>
-        </p:spPr>
-        <p:style>
-          <a:lnRef idx="1">
-            <a:schemeClr val="accent1"/>
-          </a:lnRef>
-          <a:fillRef idx="3">
-            <a:schemeClr val="accent1"/>
-          </a:fillRef>
-          <a:effectRef idx="2">
-            <a:schemeClr val="accent1"/>
-          </a:effectRef>
-          <a:fontRef idx="minor">
-            <a:schemeClr val="lt1"/>
-          </a:fontRef>
-        </p:style>
-        <p:txBody>
-          <a:bodyPr rtlCol="0" anchor="ctr"/>
-          <a:lstStyle/>
-          <a:p>
-            <a:pPr algn="ctr"/>
-          </a:p>
-        </p:txBody>
-      </p:sp>
-      <p:sp>
-        <p:nvSpPr>
-          <p:cNvPr id="15" name="TextBox 14"/>
+          <p:cNvPr id="20" name="TextBox 19"/>
           <p:cNvSpPr txBox="1"/>
           <p:nvPr/>
         </p:nvSpPr>
         <p:spPr>
           <a:xfrm>
-            <a:off x="4523232" y="1673351"/>
-            <a:ext cx="731520" cy="256032"/>
-          </a:xfrm>
-          <a:prstGeom prst="rect">
-            <a:avLst/>
-          </a:prstGeom>
-          <a:noFill/>
-        </p:spPr>
-        <p:txBody>
-          <a:bodyPr wrap="square" anchor="t" lIns="0" rIns="0" tIns="0" bIns="0">
-            <a:spAutoFit/>
-          </a:bodyPr>
-          <a:lstStyle/>
-          <a:p>
-            <a:pPr algn="ctr">
-              <a:lnSpc>
-                <a:spcPct val="108000"/>
-              </a:lnSpc>
-              <a:spcAft>
-                <a:spcPts val="300"/>
-              </a:spcAft>
-            </a:pPr>
-            <a:r>
-              <a:rPr sz="900" b="1" i="0">
-                <a:solidFill>
-                  <a:srgbClr val="FFFFFF"/>
-                </a:solidFill>
-                <a:latin typeface="Montserrat"/>
-              </a:rPr>
-              <a:t>2</a:t>
-            </a:r>
-          </a:p>
-        </p:txBody>
-      </p:sp>
-      <p:sp>
-        <p:nvSpPr>
-          <p:cNvPr id="16" name="TextBox 15"/>
-          <p:cNvSpPr txBox="1"/>
-          <p:nvPr/>
-        </p:nvSpPr>
-        <p:spPr>
-          <a:xfrm>
-            <a:off x="4541520" y="2039112"/>
-            <a:ext cx="3078480" cy="3520439"/>
+            <a:off x="4352544" y="3959352"/>
+            <a:ext cx="3008376" cy="1965959"/>
           </a:xfrm>
           <a:prstGeom prst="rect">
             <a:avLst/>
@@ -10106,17 +10286,17 @@
                 <a:spcPts val="0"/>
               </a:spcBef>
               <a:spcAft>
-                <a:spcPts val="600"/>
+                <a:spcPts val="400"/>
               </a:spcAft>
             </a:pPr>
             <a:r>
-              <a:rPr sz="1350" b="1" i="0">
-                <a:solidFill>
-                  <a:srgbClr val="FFFFFF"/>
+              <a:rPr sz="1250" b="1" i="0">
+                <a:solidFill>
+                  <a:srgbClr val="3854CC"/>
                 </a:solidFill>
                 <a:latin typeface="Montserrat"/>
               </a:rPr>
-              <a:t>Canal común (Opie)</a:t>
+              <a:t>Hipertensión ductal retrógrada</a:t>
             </a:r>
           </a:p>
           <a:p>
@@ -10134,34 +10314,38 @@
             <a:r>
               <a:rPr sz="1100" b="0" i="0">
                 <a:solidFill>
-                  <a:srgbClr val="E0E4FF"/>
+                  <a:srgbClr val="2B2C4A"/>
                 </a:solidFill>
                 <a:latin typeface="Montserrat"/>
               </a:rPr>
-              <a:t>Impactación litiásica transitoria en la ampolla de Vater y el esfínter de Oddi.</a:t>
-            </a:r>
-          </a:p>
-        </p:txBody>
-      </p:sp>
-      <p:sp>
-        <p:nvSpPr>
-          <p:cNvPr id="17" name="Right Arrow 16"/>
+              <a:t>Obstrucción del conducto de Wirsung: estasis de secreción rica en zimógenos e hiperpresión intraductal.</a:t>
+            </a:r>
+          </a:p>
+        </p:txBody>
+      </p:sp>
+      <p:sp>
+        <p:nvSpPr>
+          <p:cNvPr id="21" name="Rounded Rectangle 20"/>
           <p:cNvSpPr/>
           <p:nvPr/>
         </p:nvSpPr>
         <p:spPr>
           <a:xfrm>
-            <a:off x="7848600" y="3502151"/>
-            <a:ext cx="228599" cy="219456"/>
-          </a:xfrm>
-          <a:prstGeom prst="rightArrow">
-            <a:avLst/>
+            <a:off x="7690104" y="2619340"/>
+            <a:ext cx="3913632" cy="2167959"/>
+          </a:xfrm>
+          <a:prstGeom prst="roundRect">
+            <a:avLst>
+              <a:gd name="adj" fmla="val 2000"/>
+            </a:avLst>
           </a:prstGeom>
           <a:solidFill>
-            <a:srgbClr val="D92A2B"/>
+            <a:srgbClr val="FFFFFF"/>
           </a:solidFill>
-          <a:ln>
-            <a:noFill/>
+          <a:ln w="9525">
+            <a:solidFill>
+              <a:srgbClr val="D9DDF2"/>
+            </a:solidFill>
           </a:ln>
           <a:effectLst/>
         </p:spPr>
@@ -10187,110 +10371,40 @@
           </a:p>
         </p:txBody>
       </p:sp>
-      <p:sp>
-        <p:nvSpPr>
-          <p:cNvPr id="18" name="Rounded Rectangle 17"/>
-          <p:cNvSpPr/>
-          <p:nvPr/>
-        </p:nvSpPr>
-        <p:spPr>
-          <a:xfrm>
-            <a:off x="8122920" y="1508760"/>
-            <a:ext cx="3444240" cy="4206240"/>
-          </a:xfrm>
-          <a:prstGeom prst="roundRect">
-            <a:avLst>
-              <a:gd name="adj" fmla="val 4000"/>
-            </a:avLst>
-          </a:prstGeom>
-          <a:solidFill>
-            <a:srgbClr val="FFFFFF"/>
-          </a:solidFill>
-          <a:ln w="7620">
-            <a:solidFill>
-              <a:srgbClr val="D9DDF2"/>
-            </a:solidFill>
-          </a:ln>
-          <a:effectLst/>
-        </p:spPr>
-        <p:style>
-          <a:lnRef idx="1">
-            <a:schemeClr val="accent1"/>
-          </a:lnRef>
-          <a:fillRef idx="3">
-            <a:schemeClr val="accent1"/>
-          </a:fillRef>
-          <a:effectRef idx="2">
-            <a:schemeClr val="accent1"/>
-          </a:effectRef>
-          <a:fontRef idx="minor">
-            <a:schemeClr val="lt1"/>
-          </a:fontRef>
-        </p:style>
-        <p:txBody>
-          <a:bodyPr rtlCol="0" anchor="ctr"/>
-          <a:lstStyle/>
-          <a:p>
-            <a:pPr algn="ctr"/>
-          </a:p>
-        </p:txBody>
-      </p:sp>
-      <p:sp>
-        <p:nvSpPr>
-          <p:cNvPr id="19" name="Rounded Rectangle 18"/>
-          <p:cNvSpPr/>
-          <p:nvPr/>
-        </p:nvSpPr>
-        <p:spPr>
-          <a:xfrm>
-            <a:off x="8287512" y="1673351"/>
-            <a:ext cx="731520" cy="256032"/>
-          </a:xfrm>
-          <a:prstGeom prst="roundRect">
-            <a:avLst>
-              <a:gd name="adj" fmla="val 8000"/>
-            </a:avLst>
-          </a:prstGeom>
-          <a:solidFill>
-            <a:srgbClr val="EEF0FF"/>
-          </a:solidFill>
-          <a:ln>
-            <a:noFill/>
-          </a:ln>
-          <a:effectLst/>
-        </p:spPr>
-        <p:style>
-          <a:lnRef idx="1">
-            <a:schemeClr val="accent1"/>
-          </a:lnRef>
-          <a:fillRef idx="3">
-            <a:schemeClr val="accent1"/>
-          </a:fillRef>
-          <a:effectRef idx="2">
-            <a:schemeClr val="accent1"/>
-          </a:effectRef>
-          <a:fontRef idx="minor">
-            <a:schemeClr val="lt1"/>
-          </a:fontRef>
-        </p:style>
-        <p:txBody>
-          <a:bodyPr rtlCol="0" anchor="ctr"/>
-          <a:lstStyle/>
-          <a:p>
-            <a:pPr algn="ctr"/>
-          </a:p>
-        </p:txBody>
-      </p:sp>
-      <p:sp>
-        <p:nvSpPr>
-          <p:cNvPr id="20" name="TextBox 19"/>
+      <p:pic>
+        <p:nvPicPr>
+          <p:cNvPr id="22" name="Picture 21" descr="esquema_obstruccion_ampular.png"/>
+          <p:cNvPicPr>
+            <a:picLocks noChangeAspect="1"/>
+          </p:cNvPicPr>
+          <p:nvPr/>
+        </p:nvPicPr>
+        <p:blipFill>
+          <a:blip r:embed="rId2"/>
+          <a:stretch>
+            <a:fillRect/>
+          </a:stretch>
+        </p:blipFill>
+        <p:spPr>
+          <a:xfrm>
+            <a:off x="7726679" y="2655916"/>
+            <a:ext cx="3840480" cy="2094807"/>
+          </a:xfrm>
+          <a:prstGeom prst="rect">
+            <a:avLst/>
+          </a:prstGeom>
+        </p:spPr>
+      </p:pic>
+      <p:sp>
+        <p:nvSpPr>
+          <p:cNvPr id="23" name="TextBox 22"/>
           <p:cNvSpPr txBox="1"/>
           <p:nvPr/>
         </p:nvSpPr>
         <p:spPr>
           <a:xfrm>
-            <a:off x="8287512" y="1673351"/>
-            <a:ext cx="731520" cy="256032"/>
+            <a:off x="594360" y="6053328"/>
+            <a:ext cx="10972800" cy="256032"/>
           </a:xfrm>
           <a:prstGeom prst="rect">
             <a:avLst/>
@@ -10303,7 +10417,7 @@
           </a:bodyPr>
           <a:lstStyle/>
           <a:p>
-            <a:pPr algn="ctr">
+            <a:pPr algn="l">
               <a:lnSpc>
                 <a:spcPct val="108000"/>
               </a:lnSpc>
@@ -10312,80 +10426,13 @@
               </a:spcAft>
             </a:pPr>
             <a:r>
-              <a:rPr sz="900" b="1" i="0">
-                <a:solidFill>
-                  <a:srgbClr val="3854CC"/>
+              <a:rPr sz="900" b="0" i="1">
+                <a:solidFill>
+                  <a:srgbClr val="606383"/>
                 </a:solidFill>
                 <a:latin typeface="Montserrat"/>
               </a:rPr>
-              <a:t>3</a:t>
-            </a:r>
-          </a:p>
-        </p:txBody>
-      </p:sp>
-      <p:sp>
-        <p:nvSpPr>
-          <p:cNvPr id="21" name="TextBox 20"/>
-          <p:cNvSpPr txBox="1"/>
-          <p:nvPr/>
-        </p:nvSpPr>
-        <p:spPr>
-          <a:xfrm>
-            <a:off x="8305800" y="2039112"/>
-            <a:ext cx="3078480" cy="3520439"/>
-          </a:xfrm>
-          <a:prstGeom prst="rect">
-            <a:avLst/>
-          </a:prstGeom>
-          <a:noFill/>
-        </p:spPr>
-        <p:txBody>
-          <a:bodyPr wrap="square" anchor="t" lIns="0" rIns="0" tIns="0" bIns="0">
-            <a:spAutoFit/>
-          </a:bodyPr>
-          <a:lstStyle/>
-          <a:p>
-            <a:pPr algn="l">
-              <a:lnSpc>
-                <a:spcPct val="108000"/>
-              </a:lnSpc>
-              <a:spcBef>
-                <a:spcPts val="0"/>
-              </a:spcBef>
-              <a:spcAft>
-                <a:spcPts val="600"/>
-              </a:spcAft>
-            </a:pPr>
-            <a:r>
-              <a:rPr sz="1350" b="1" i="0">
-                <a:solidFill>
-                  <a:srgbClr val="3854CC"/>
-                </a:solidFill>
-                <a:latin typeface="Montserrat"/>
-              </a:rPr>
-              <a:t>Hipertensión ductal retrógrada</a:t>
-            </a:r>
-          </a:p>
-          <a:p>
-            <a:pPr algn="l">
-              <a:lnSpc>
-                <a:spcPct val="110000"/>
-              </a:lnSpc>
-              <a:spcBef>
-                <a:spcPts val="0"/>
-              </a:spcBef>
-              <a:spcAft>
-                <a:spcPts val="300"/>
-              </a:spcAft>
-            </a:pPr>
-            <a:r>
-              <a:rPr sz="1100" b="0" i="0">
-                <a:solidFill>
-                  <a:srgbClr val="2B2C4A"/>
-                </a:solidFill>
-                <a:latin typeface="Montserrat"/>
-              </a:rPr>
-              <a:t>Obstrucción del conducto de Wirsung: estasis de secreción rica en zimógenos e hiperpresión intraductal.</a:t>
+              <a:t>Ilustración de apoyo: el diagnóstico se apoya en la clínica y en la bioquímica.  •  Crédito: Esquema ilustrativo generado por IA; revisión anatómica del equipo según la fuente.</a:t>
             </a:r>
           </a:p>
         </p:txBody>
@@ -11109,7 +11156,7 @@
                 </a:solidFill>
                 <a:latin typeface="Montserrat"/>
               </a:rPr>
-              <a:t>Hidrólisis prematura del tripsinógeno en tripsina activa intracelular.</a:t>
+              <a:t>La catepsina B hidroliza el tripsinógeno en tripsina activa intracelular, antes de tiempo.</a:t>
             </a:r>
           </a:p>
         </p:txBody>
@@ -11603,7 +11650,7 @@
                 </a:solidFill>
                 <a:latin typeface="Montserrat"/>
               </a:rPr>
-              <a:t>TNF-α, IL-1, IL-6 e histamina aumentan la permeabilidad capilar y secuestran líquido en el tercer espacio.</a:t>
+              <a:t>TNF-α, IL-1, IL-6 e histamina aumentan la permeabilidad capilar, secuestran volumen en el tercer espacio y predisponen a choque distributivo.</a:t>
             </a:r>
           </a:p>
         </p:txBody>
@@ -12009,7 +12056,7 @@
                 </a:solidFill>
                 <a:latin typeface="Montserrat"/>
               </a:rPr>
-              <a:t>Edema pálido pancreático con placas en "gotas de vela" en grasa peripancreática: esteatonecrosis.</a:t>
+              <a:t>Aumento de volumen con edema pálido y placas en "gotas de vela" en la grasa peripancreática.</a:t>
             </a:r>
           </a:p>
         </p:txBody>
@@ -12051,7 +12098,7 @@
                 </a:solidFill>
                 <a:latin typeface="Montserrat"/>
               </a:rPr>
-              <a:t>Flecha 1: aumento volumétrico y edema pálido. Flecha 2: placas blanquecinas en grasa. Sin necrosis masiva ni hemorragia.  •  Crédito: Fuente: Caso Clínico 09 (UCP), archivo original. Pendiente de reinserción.</a:t>
+              <a:t>Flecha 1: aumento de volumen y edema pálido. Flecha 2: placas en grasa. Sin necrosis masiva.  •  Crédito: Fuente: Caso Clínico 09 (UCP), archivo original. Pendiente de reinserción.</a:t>
             </a:r>
           </a:p>
         </p:txBody>
@@ -12457,7 +12504,7 @@
                 </a:solidFill>
                 <a:latin typeface="Montserrat"/>
               </a:rPr>
-              <a:t>Adipocitos fantasma con sales cálcicas y neutrófilos en septos: esteatonecrosis aguda.</a:t>
+              <a:t>Adipocitos fantasma con material basófilo y neutrófilos en septos: saponificación aguda.</a:t>
             </a:r>
           </a:p>
         </p:txBody>
@@ -12499,7 +12546,7 @@
                 </a:solidFill>
                 <a:latin typeface="Montserrat"/>
               </a:rPr>
-              <a:t>Fantasmas de adipocitos anucleados con material basófilo amorfo; congestión e infiltrado neutrofílico en septos interlobulillares.  •  Crédito: Fuente: Caso Clínico 09 (UCP), archivo original. Pendiente de reinserción.</a:t>
+              <a:t>Adipocitos anucleados con material basófilo amorfo; congestión e infiltrado neutrofílico.  •  Crédito: Fuente: Caso Clínico 09 (UCP), archivo original. Pendiente de reinserción.</a:t>
             </a:r>
           </a:p>
         </p:txBody>
@@ -12858,7 +12905,7 @@
                           </a:solidFill>
                           <a:latin typeface="Montserrat"/>
                         </a:rPr>
-                        <a:t>HALLAZGO O INDICACIÓN</a:t>
+                        <a:t>HALLAZGO CLAVE</a:t>
                       </a:r>
                     </a:p>
                   </a:txBody>
@@ -12891,7 +12938,7 @@
                           </a:solidFill>
                           <a:latin typeface="Montserrat"/>
                         </a:rPr>
-                        <a:t>VALOR EN EL CASO</a:t>
+                        <a:t>LECTURA CLÍNICA</a:t>
                       </a:r>
                     </a:p>
                   </a:txBody>
@@ -13060,7 +13107,7 @@
                           </a:solidFill>
                           <a:latin typeface="Montserrat"/>
                         </a:rPr>
-                        <a:t>Indicada a las 72–96 h del inicio; atenuación homogénea y colecciones agudas</a:t>
+                        <a:t>Indicada a las 72–96 h; atenuación homogénea y colecciones líquidas agudas</a:t>
                       </a:r>
                     </a:p>
                   </a:txBody>
@@ -13093,7 +13140,7 @@
                           </a:solidFill>
                           <a:latin typeface="Montserrat"/>
                         </a:rPr>
-                        <a:t>Balthazar C/D sin necrosis parenquimatosa</a:t>
+                        <a:t>Balthazar C/D, sin necrosis parenquimatosa</a:t>
                       </a:r>
                     </a:p>
                   </a:txBody>
@@ -13194,7 +13241,7 @@
                           </a:solidFill>
                           <a:latin typeface="Montserrat"/>
                         </a:rPr>
-                        <a:t>Identifica litiasis vesicular</a:t>
+                        <a:t>Identifica la litiasis vesicular como etiología</a:t>
                       </a:r>
                     </a:p>
                   </a:txBody>
@@ -13294,7 +13341,7 @@
                 </a:solidFill>
                 <a:latin typeface="Montserrat"/>
               </a:rPr>
-              <a:t>CONCLUSIÓN EDITORIAL:  La TC a las 72–96 h evita subestimar la necrosis: aquí la forma es edematosa.</a:t>
+              <a:t>CONCLUSIÓN EDITORIAL:  La TC a las 72–96 h evita subestimar la necrosis; en este caso la forma es edematosa.</a:t>
             </a:r>
           </a:p>
         </p:txBody>

</xml_diff>

<commit_message>
Add slide 13: ultrasound differential table as sabatina annex
Annex slide placed after the 12-slide sequence so the presentation order is unchanged.
Lint PASS (13 slides), contrast 0 violations.

Co-authored-by: arena-agent <297053741+arena-agent@users.noreply.github.com>
</commit_message>
<xml_diff>
--- a/entregas-es/pancreatitis-biliar/Pancreatitis_biliar_12_diapositivas_es.pptx
+++ b/entregas-es/pancreatitis-biliar/Pancreatitis_biliar_12_diapositivas_es.pptx
@@ -17,6 +17,7 @@
     <p:sldId id="265" r:id="rId16"/>
     <p:sldId id="266" r:id="rId17"/>
     <p:sldId id="267" r:id="rId18"/>
+    <p:sldId id="268" r:id="rId19"/>
   </p:sldIdLst>
   <p:sldSz cx="12191695" cy="6858000" type="screen4x3"/>
   <p:notesSz cx="6858000" cy="9144000"/>
@@ -6662,6 +6663,944 @@
                 <a:latin typeface="Montserrat"/>
               </a:rPr>
               <a:t>Títulos abreviados por espacio; citas completas en el PDF adjunto.</a:t>
+            </a:r>
+          </a:p>
+        </p:txBody>
+      </p:sp>
+    </p:spTree>
+  </p:cSld>
+  <p:clrMapOvr>
+    <a:masterClrMapping/>
+  </p:clrMapOvr>
+</p:sld>
+</file>
+
+<file path=ppt/slides/slide13.xml><?xml version="1.0" encoding="utf-8"?>
+<p:sld xmlns:a="http://schemas.openxmlformats.org/drawingml/2006/main" xmlns:p="http://schemas.openxmlformats.org/presentationml/2006/main" xmlns:r="http://schemas.openxmlformats.org/officeDocument/2006/relationships">
+  <p:cSld>
+    <p:spTree>
+      <p:nvGrpSpPr>
+        <p:cNvPr id="1" name=""/>
+        <p:cNvGrpSpPr/>
+        <p:nvPr/>
+      </p:nvGrpSpPr>
+      <p:grpSpPr/>
+      <p:sp>
+        <p:nvSpPr>
+          <p:cNvPr id="2" name="TextBox 1"/>
+          <p:cNvSpPr txBox="1"/>
+          <p:nvPr/>
+        </p:nvSpPr>
+        <p:spPr>
+          <a:xfrm>
+            <a:off x="594360" y="292608"/>
+            <a:ext cx="10058400" cy="219456"/>
+          </a:xfrm>
+          <a:prstGeom prst="rect">
+            <a:avLst/>
+          </a:prstGeom>
+          <a:noFill/>
+        </p:spPr>
+        <p:txBody>
+          <a:bodyPr wrap="square" anchor="t" lIns="0" rIns="0" tIns="0" bIns="0">
+            <a:spAutoFit/>
+          </a:bodyPr>
+          <a:lstStyle/>
+          <a:p>
+            <a:pPr algn="l">
+              <a:lnSpc>
+                <a:spcPct val="108000"/>
+              </a:lnSpc>
+              <a:spcAft>
+                <a:spcPts val="300"/>
+              </a:spcAft>
+            </a:pPr>
+            <a:r>
+              <a:rPr sz="950" b="1" i="0">
+                <a:solidFill>
+                  <a:srgbClr val="CA2728"/>
+                </a:solidFill>
+                <a:latin typeface="Montserrat"/>
+              </a:rPr>
+              <a:t>ANEXO · IMAGENOLOGÍA</a:t>
+            </a:r>
+          </a:p>
+        </p:txBody>
+      </p:sp>
+      <p:sp>
+        <p:nvSpPr>
+          <p:cNvPr id="3" name="TextBox 2"/>
+          <p:cNvSpPr txBox="1"/>
+          <p:nvPr/>
+        </p:nvSpPr>
+        <p:spPr>
+          <a:xfrm>
+            <a:off x="594360" y="530352"/>
+            <a:ext cx="10972800" cy="594360"/>
+          </a:xfrm>
+          <a:prstGeom prst="rect">
+            <a:avLst/>
+          </a:prstGeom>
+          <a:noFill/>
+        </p:spPr>
+        <p:txBody>
+          <a:bodyPr wrap="square" anchor="t" lIns="0" rIns="0" tIns="0" bIns="0">
+            <a:spAutoFit/>
+          </a:bodyPr>
+          <a:lstStyle/>
+          <a:p>
+            <a:pPr algn="l">
+              <a:lnSpc>
+                <a:spcPct val="108000"/>
+              </a:lnSpc>
+              <a:spcAft>
+                <a:spcPts val="300"/>
+              </a:spcAft>
+            </a:pPr>
+            <a:r>
+              <a:rPr sz="2300" b="1" i="0">
+                <a:solidFill>
+                  <a:srgbClr val="3854CC"/>
+                </a:solidFill>
+                <a:latin typeface="Montserrat"/>
+              </a:rPr>
+              <a:t>Ecografía vesicular: cálculo, barro y pólipo</a:t>
+            </a:r>
+          </a:p>
+        </p:txBody>
+      </p:sp>
+      <p:sp>
+        <p:nvSpPr>
+          <p:cNvPr id="4" name="Rectangle 3"/>
+          <p:cNvSpPr/>
+          <p:nvPr/>
+        </p:nvSpPr>
+        <p:spPr>
+          <a:xfrm>
+            <a:off x="594360" y="1170432"/>
+            <a:ext cx="1188720" cy="27432"/>
+          </a:xfrm>
+          <a:prstGeom prst="rect">
+            <a:avLst/>
+          </a:prstGeom>
+          <a:solidFill>
+            <a:srgbClr val="D92A2B"/>
+          </a:solidFill>
+          <a:ln>
+            <a:noFill/>
+          </a:ln>
+          <a:effectLst/>
+        </p:spPr>
+        <p:style>
+          <a:lnRef idx="1">
+            <a:schemeClr val="accent1"/>
+          </a:lnRef>
+          <a:fillRef idx="3">
+            <a:schemeClr val="accent1"/>
+          </a:fillRef>
+          <a:effectRef idx="2">
+            <a:schemeClr val="accent1"/>
+          </a:effectRef>
+          <a:fontRef idx="minor">
+            <a:schemeClr val="lt1"/>
+          </a:fontRef>
+        </p:style>
+        <p:txBody>
+          <a:bodyPr rtlCol="0" anchor="ctr"/>
+          <a:lstStyle/>
+          <a:p>
+            <a:pPr algn="ctr"/>
+          </a:p>
+        </p:txBody>
+      </p:sp>
+      <p:sp>
+        <p:nvSpPr>
+          <p:cNvPr id="5" name="Rectangle 4"/>
+          <p:cNvSpPr/>
+          <p:nvPr/>
+        </p:nvSpPr>
+        <p:spPr>
+          <a:xfrm>
+            <a:off x="1810512" y="1179576"/>
+            <a:ext cx="9784080" cy="9144"/>
+          </a:xfrm>
+          <a:prstGeom prst="rect">
+            <a:avLst/>
+          </a:prstGeom>
+          <a:solidFill>
+            <a:srgbClr val="D9DDF2"/>
+          </a:solidFill>
+          <a:ln>
+            <a:noFill/>
+          </a:ln>
+          <a:effectLst/>
+        </p:spPr>
+        <p:style>
+          <a:lnRef idx="1">
+            <a:schemeClr val="accent1"/>
+          </a:lnRef>
+          <a:fillRef idx="3">
+            <a:schemeClr val="accent1"/>
+          </a:fillRef>
+          <a:effectRef idx="2">
+            <a:schemeClr val="accent1"/>
+          </a:effectRef>
+          <a:fontRef idx="minor">
+            <a:schemeClr val="lt1"/>
+          </a:fontRef>
+        </p:style>
+        <p:txBody>
+          <a:bodyPr rtlCol="0" anchor="ctr"/>
+          <a:lstStyle/>
+          <a:p>
+            <a:pPr algn="ctr"/>
+          </a:p>
+        </p:txBody>
+      </p:sp>
+      <p:sp>
+        <p:nvSpPr>
+          <p:cNvPr id="6" name="TextBox 5"/>
+          <p:cNvSpPr txBox="1"/>
+          <p:nvPr/>
+        </p:nvSpPr>
+        <p:spPr>
+          <a:xfrm>
+            <a:off x="594360" y="6382512"/>
+            <a:ext cx="7772400" cy="256032"/>
+          </a:xfrm>
+          <a:prstGeom prst="rect">
+            <a:avLst/>
+          </a:prstGeom>
+          <a:noFill/>
+        </p:spPr>
+        <p:txBody>
+          <a:bodyPr wrap="square" anchor="t" lIns="0" rIns="0" tIns="0" bIns="0">
+            <a:spAutoFit/>
+          </a:bodyPr>
+          <a:lstStyle/>
+          <a:p>
+            <a:pPr algn="l">
+              <a:lnSpc>
+                <a:spcPct val="108000"/>
+              </a:lnSpc>
+              <a:spcAft>
+                <a:spcPts val="300"/>
+              </a:spcAft>
+            </a:pPr>
+            <a:r>
+              <a:rPr sz="900" b="0" i="0">
+                <a:solidFill>
+                  <a:srgbClr val="606383"/>
+                </a:solidFill>
+                <a:latin typeface="Montserrat"/>
+              </a:rPr>
+              <a:t>UNIVERSIDAD CENTRAL DEL PARAGUAY (UCP) · CARRERA DE MEDICINA</a:t>
+            </a:r>
+          </a:p>
+        </p:txBody>
+      </p:sp>
+      <p:sp>
+        <p:nvSpPr>
+          <p:cNvPr id="7" name="TextBox 6"/>
+          <p:cNvSpPr txBox="1"/>
+          <p:nvPr/>
+        </p:nvSpPr>
+        <p:spPr>
+          <a:xfrm>
+            <a:off x="10789920" y="6382512"/>
+            <a:ext cx="822960" cy="256032"/>
+          </a:xfrm>
+          <a:prstGeom prst="rect">
+            <a:avLst/>
+          </a:prstGeom>
+          <a:noFill/>
+        </p:spPr>
+        <p:txBody>
+          <a:bodyPr wrap="square" anchor="t" lIns="0" rIns="0" tIns="0" bIns="0">
+            <a:spAutoFit/>
+          </a:bodyPr>
+          <a:lstStyle/>
+          <a:p>
+            <a:pPr algn="r">
+              <a:lnSpc>
+                <a:spcPct val="108000"/>
+              </a:lnSpc>
+              <a:spcAft>
+                <a:spcPts val="300"/>
+              </a:spcAft>
+            </a:pPr>
+            <a:r>
+              <a:rPr sz="900" b="1" i="0">
+                <a:solidFill>
+                  <a:srgbClr val="606383"/>
+                </a:solidFill>
+                <a:latin typeface="Montserrat"/>
+              </a:rPr>
+              <a:t>13</a:t>
+            </a:r>
+          </a:p>
+        </p:txBody>
+      </p:sp>
+      <p:graphicFrame>
+        <p:nvGraphicFramePr>
+          <p:cNvPr id="8" name="Table 7"/>
+          <p:cNvGraphicFramePr>
+            <a:graphicFrameLocks noGrp="1"/>
+          </p:cNvGraphicFramePr>
+          <p:nvPr/>
+        </p:nvGraphicFramePr>
+        <p:xfrm>
+          <a:off x="594360" y="1463040"/>
+          <a:ext cx="10972799" cy="3749039"/>
+        </p:xfrm>
+        <a:graphic>
+          <a:graphicData uri="http://schemas.openxmlformats.org/drawingml/2006/table">
+            <a:tbl>
+              <a:tblPr firstRow="1" bandRow="1">
+                <a:tableStyleId>{5C22544A-7EE6-4342-B048-85BDC9FD1C3A}</a:tableStyleId>
+              </a:tblPr>
+              <a:tblGrid>
+                <a:gridCol w="2560319"/>
+                <a:gridCol w="4754880"/>
+                <a:gridCol w="3657600"/>
+              </a:tblGrid>
+              <a:tr h="749807">
+                <a:tc>
+                  <a:txBody>
+                    <a:bodyPr wrap="square"/>
+                    <a:lstStyle/>
+                    <a:p>
+                      <a:pPr algn="l">
+                        <a:lnSpc>
+                          <a:spcPct val="108000"/>
+                        </a:lnSpc>
+                        <a:spcBef>
+                          <a:spcPts val="0"/>
+                        </a:spcBef>
+                        <a:spcAft>
+                          <a:spcPts val="0"/>
+                        </a:spcAft>
+                      </a:pPr>
+                      <a:r>
+                        <a:rPr sz="1100" b="1" i="0">
+                          <a:solidFill>
+                            <a:srgbClr val="FFFFFF"/>
+                          </a:solidFill>
+                          <a:latin typeface="Montserrat"/>
+                        </a:rPr>
+                        <a:t>HALLAZGO</a:t>
+                      </a:r>
+                    </a:p>
+                  </a:txBody>
+                  <a:tcPr marL="128016" marR="128016" marT="73152" marB="73152">
+                    <a:solidFill>
+                      <a:srgbClr val="3854CC"/>
+                    </a:solidFill>
+                  </a:tcPr>
+                </a:tc>
+                <a:tc>
+                  <a:txBody>
+                    <a:bodyPr wrap="square"/>
+                    <a:lstStyle/>
+                    <a:p>
+                      <a:pPr algn="l">
+                        <a:lnSpc>
+                          <a:spcPct val="108000"/>
+                        </a:lnSpc>
+                        <a:spcBef>
+                          <a:spcPts val="0"/>
+                        </a:spcBef>
+                        <a:spcAft>
+                          <a:spcPts val="0"/>
+                        </a:spcAft>
+                      </a:pPr>
+                      <a:r>
+                        <a:rPr sz="1100" b="1" i="0">
+                          <a:solidFill>
+                            <a:srgbClr val="FFFFFF"/>
+                          </a:solidFill>
+                          <a:latin typeface="Montserrat"/>
+                        </a:rPr>
+                        <a:t>ECOGENICIDAD Y MOVILIDAD</a:t>
+                      </a:r>
+                    </a:p>
+                  </a:txBody>
+                  <a:tcPr marL="128016" marR="128016" marT="73152" marB="73152">
+                    <a:solidFill>
+                      <a:srgbClr val="3854CC"/>
+                    </a:solidFill>
+                  </a:tcPr>
+                </a:tc>
+                <a:tc>
+                  <a:txBody>
+                    <a:bodyPr wrap="square"/>
+                    <a:lstStyle/>
+                    <a:p>
+                      <a:pPr algn="l">
+                        <a:lnSpc>
+                          <a:spcPct val="108000"/>
+                        </a:lnSpc>
+                        <a:spcBef>
+                          <a:spcPts val="0"/>
+                        </a:spcBef>
+                        <a:spcAft>
+                          <a:spcPts val="0"/>
+                        </a:spcAft>
+                      </a:pPr>
+                      <a:r>
+                        <a:rPr sz="1100" b="1" i="0">
+                          <a:solidFill>
+                            <a:srgbClr val="FFFFFF"/>
+                          </a:solidFill>
+                          <a:latin typeface="Montserrat"/>
+                        </a:rPr>
+                        <a:t>SOMBRA POSTERIOR / CLAVE</a:t>
+                      </a:r>
+                    </a:p>
+                  </a:txBody>
+                  <a:tcPr marL="128016" marR="128016" marT="73152" marB="73152">
+                    <a:solidFill>
+                      <a:srgbClr val="3854CC"/>
+                    </a:solidFill>
+                  </a:tcPr>
+                </a:tc>
+              </a:tr>
+              <a:tr h="749807">
+                <a:tc>
+                  <a:txBody>
+                    <a:bodyPr wrap="square"/>
+                    <a:lstStyle/>
+                    <a:p>
+                      <a:pPr algn="l">
+                        <a:lnSpc>
+                          <a:spcPct val="105000"/>
+                        </a:lnSpc>
+                        <a:spcBef>
+                          <a:spcPts val="0"/>
+                        </a:spcBef>
+                        <a:spcAft>
+                          <a:spcPts val="0"/>
+                        </a:spcAft>
+                      </a:pPr>
+                      <a:r>
+                        <a:rPr sz="1100" b="1" i="0">
+                          <a:solidFill>
+                            <a:srgbClr val="3854CC"/>
+                          </a:solidFill>
+                          <a:latin typeface="Montserrat"/>
+                        </a:rPr>
+                        <a:t>Bilis normal</a:t>
+                      </a:r>
+                    </a:p>
+                  </a:txBody>
+                  <a:tcPr marL="128016" marR="128016" marT="54864" marB="54864">
+                    <a:solidFill>
+                      <a:srgbClr val="FFFFFF"/>
+                    </a:solidFill>
+                  </a:tcPr>
+                </a:tc>
+                <a:tc>
+                  <a:txBody>
+                    <a:bodyPr wrap="square"/>
+                    <a:lstStyle/>
+                    <a:p>
+                      <a:pPr algn="l">
+                        <a:lnSpc>
+                          <a:spcPct val="105000"/>
+                        </a:lnSpc>
+                        <a:spcBef>
+                          <a:spcPts val="0"/>
+                        </a:spcBef>
+                        <a:spcAft>
+                          <a:spcPts val="0"/>
+                        </a:spcAft>
+                      </a:pPr>
+                      <a:r>
+                        <a:rPr sz="1100" b="0" i="0">
+                          <a:solidFill>
+                            <a:srgbClr val="2B2C4A"/>
+                          </a:solidFill>
+                          <a:latin typeface="Montserrat"/>
+                        </a:rPr>
+                        <a:t>Anecoica; vesícula distendida.</a:t>
+                      </a:r>
+                    </a:p>
+                  </a:txBody>
+                  <a:tcPr marL="128016" marR="128016" marT="54864" marB="54864">
+                    <a:solidFill>
+                      <a:srgbClr val="FFFFFF"/>
+                    </a:solidFill>
+                  </a:tcPr>
+                </a:tc>
+                <a:tc>
+                  <a:txBody>
+                    <a:bodyPr wrap="square"/>
+                    <a:lstStyle/>
+                    <a:p>
+                      <a:pPr algn="l">
+                        <a:lnSpc>
+                          <a:spcPct val="105000"/>
+                        </a:lnSpc>
+                        <a:spcBef>
+                          <a:spcPts val="0"/>
+                        </a:spcBef>
+                        <a:spcAft>
+                          <a:spcPts val="0"/>
+                        </a:spcAft>
+                      </a:pPr>
+                      <a:r>
+                        <a:rPr sz="1100" b="0" i="0">
+                          <a:solidFill>
+                            <a:srgbClr val="2B2C4A"/>
+                          </a:solidFill>
+                          <a:latin typeface="Montserrat"/>
+                        </a:rPr>
+                        <a:t>Luz sin ecos internos.</a:t>
+                      </a:r>
+                    </a:p>
+                  </a:txBody>
+                  <a:tcPr marL="128016" marR="128016" marT="54864" marB="54864">
+                    <a:solidFill>
+                      <a:srgbClr val="FFFFFF"/>
+                    </a:solidFill>
+                  </a:tcPr>
+                </a:tc>
+              </a:tr>
+              <a:tr h="749807">
+                <a:tc>
+                  <a:txBody>
+                    <a:bodyPr wrap="square"/>
+                    <a:lstStyle/>
+                    <a:p>
+                      <a:pPr algn="l">
+                        <a:lnSpc>
+                          <a:spcPct val="105000"/>
+                        </a:lnSpc>
+                        <a:spcBef>
+                          <a:spcPts val="0"/>
+                        </a:spcBef>
+                        <a:spcAft>
+                          <a:spcPts val="0"/>
+                        </a:spcAft>
+                      </a:pPr>
+                      <a:r>
+                        <a:rPr sz="1100" b="1" i="0">
+                          <a:solidFill>
+                            <a:srgbClr val="3854CC"/>
+                          </a:solidFill>
+                          <a:latin typeface="Montserrat"/>
+                        </a:rPr>
+                        <a:t>Cálculo</a:t>
+                      </a:r>
+                    </a:p>
+                  </a:txBody>
+                  <a:tcPr marL="128016" marR="128016" marT="54864" marB="54864">
+                    <a:solidFill>
+                      <a:srgbClr val="EEF0FF"/>
+                    </a:solidFill>
+                  </a:tcPr>
+                </a:tc>
+                <a:tc>
+                  <a:txBody>
+                    <a:bodyPr wrap="square"/>
+                    <a:lstStyle/>
+                    <a:p>
+                      <a:pPr algn="l">
+                        <a:lnSpc>
+                          <a:spcPct val="105000"/>
+                        </a:lnSpc>
+                        <a:spcBef>
+                          <a:spcPts val="0"/>
+                        </a:spcBef>
+                        <a:spcAft>
+                          <a:spcPts val="0"/>
+                        </a:spcAft>
+                      </a:pPr>
+                      <a:r>
+                        <a:rPr sz="1100" b="0" i="0">
+                          <a:solidFill>
+                            <a:srgbClr val="2B2C4A"/>
+                          </a:solidFill>
+                          <a:latin typeface="Montserrat"/>
+                        </a:rPr>
+                        <a:t>Hiperecogénico; suele moverse con el decúbito.</a:t>
+                      </a:r>
+                    </a:p>
+                  </a:txBody>
+                  <a:tcPr marL="128016" marR="128016" marT="54864" marB="54864">
+                    <a:solidFill>
+                      <a:srgbClr val="EEF0FF"/>
+                    </a:solidFill>
+                  </a:tcPr>
+                </a:tc>
+                <a:tc>
+                  <a:txBody>
+                    <a:bodyPr wrap="square"/>
+                    <a:lstStyle/>
+                    <a:p>
+                      <a:pPr algn="l">
+                        <a:lnSpc>
+                          <a:spcPct val="105000"/>
+                        </a:lnSpc>
+                        <a:spcBef>
+                          <a:spcPts val="0"/>
+                        </a:spcBef>
+                        <a:spcAft>
+                          <a:spcPts val="0"/>
+                        </a:spcAft>
+                      </a:pPr>
+                      <a:r>
+                        <a:rPr sz="1100" b="0" i="0">
+                          <a:solidFill>
+                            <a:srgbClr val="2B2C4A"/>
+                          </a:solidFill>
+                          <a:latin typeface="Montserrat"/>
+                        </a:rPr>
+                        <a:t>Sombra acústica posterior.</a:t>
+                      </a:r>
+                    </a:p>
+                  </a:txBody>
+                  <a:tcPr marL="128016" marR="128016" marT="54864" marB="54864">
+                    <a:solidFill>
+                      <a:srgbClr val="EEF0FF"/>
+                    </a:solidFill>
+                  </a:tcPr>
+                </a:tc>
+              </a:tr>
+              <a:tr h="749807">
+                <a:tc>
+                  <a:txBody>
+                    <a:bodyPr wrap="square"/>
+                    <a:lstStyle/>
+                    <a:p>
+                      <a:pPr algn="l">
+                        <a:lnSpc>
+                          <a:spcPct val="105000"/>
+                        </a:lnSpc>
+                        <a:spcBef>
+                          <a:spcPts val="0"/>
+                        </a:spcBef>
+                        <a:spcAft>
+                          <a:spcPts val="0"/>
+                        </a:spcAft>
+                      </a:pPr>
+                      <a:r>
+                        <a:rPr sz="1100" b="1" i="0">
+                          <a:solidFill>
+                            <a:srgbClr val="3854CC"/>
+                          </a:solidFill>
+                          <a:latin typeface="Montserrat"/>
+                        </a:rPr>
+                        <a:t>Barro biliar</a:t>
+                      </a:r>
+                    </a:p>
+                  </a:txBody>
+                  <a:tcPr marL="128016" marR="128016" marT="54864" marB="54864">
+                    <a:solidFill>
+                      <a:srgbClr val="FFFFFF"/>
+                    </a:solidFill>
+                  </a:tcPr>
+                </a:tc>
+                <a:tc>
+                  <a:txBody>
+                    <a:bodyPr wrap="square"/>
+                    <a:lstStyle/>
+                    <a:p>
+                      <a:pPr algn="l">
+                        <a:lnSpc>
+                          <a:spcPct val="105000"/>
+                        </a:lnSpc>
+                        <a:spcBef>
+                          <a:spcPts val="0"/>
+                        </a:spcBef>
+                        <a:spcAft>
+                          <a:spcPts val="0"/>
+                        </a:spcAft>
+                      </a:pPr>
+                      <a:r>
+                        <a:rPr sz="1100" b="0" i="0">
+                          <a:solidFill>
+                            <a:srgbClr val="2B2C4A"/>
+                          </a:solidFill>
+                          <a:latin typeface="Montserrat"/>
+                        </a:rPr>
+                        <a:t>Ecos bajos dependientes; se desplaza o estratifica.</a:t>
+                      </a:r>
+                    </a:p>
+                  </a:txBody>
+                  <a:tcPr marL="128016" marR="128016" marT="54864" marB="54864">
+                    <a:solidFill>
+                      <a:srgbClr val="FFFFFF"/>
+                    </a:solidFill>
+                  </a:tcPr>
+                </a:tc>
+                <a:tc>
+                  <a:txBody>
+                    <a:bodyPr wrap="square"/>
+                    <a:lstStyle/>
+                    <a:p>
+                      <a:pPr algn="l">
+                        <a:lnSpc>
+                          <a:spcPct val="105000"/>
+                        </a:lnSpc>
+                        <a:spcBef>
+                          <a:spcPts val="0"/>
+                        </a:spcBef>
+                        <a:spcAft>
+                          <a:spcPts val="0"/>
+                        </a:spcAft>
+                      </a:pPr>
+                      <a:r>
+                        <a:rPr sz="1100" b="0" i="0">
+                          <a:solidFill>
+                            <a:srgbClr val="2B2C4A"/>
+                          </a:solidFill>
+                          <a:latin typeface="Montserrat"/>
+                        </a:rPr>
+                        <a:t>Habitualmente sin sombra limpia.</a:t>
+                      </a:r>
+                    </a:p>
+                  </a:txBody>
+                  <a:tcPr marL="128016" marR="128016" marT="54864" marB="54864">
+                    <a:solidFill>
+                      <a:srgbClr val="FFFFFF"/>
+                    </a:solidFill>
+                  </a:tcPr>
+                </a:tc>
+              </a:tr>
+              <a:tr h="749811">
+                <a:tc>
+                  <a:txBody>
+                    <a:bodyPr wrap="square"/>
+                    <a:lstStyle/>
+                    <a:p>
+                      <a:pPr algn="l">
+                        <a:lnSpc>
+                          <a:spcPct val="105000"/>
+                        </a:lnSpc>
+                        <a:spcBef>
+                          <a:spcPts val="0"/>
+                        </a:spcBef>
+                        <a:spcAft>
+                          <a:spcPts val="0"/>
+                        </a:spcAft>
+                      </a:pPr>
+                      <a:r>
+                        <a:rPr sz="1100" b="1" i="0">
+                          <a:solidFill>
+                            <a:srgbClr val="3854CC"/>
+                          </a:solidFill>
+                          <a:latin typeface="Montserrat"/>
+                        </a:rPr>
+                        <a:t>Pólipo</a:t>
+                      </a:r>
+                    </a:p>
+                  </a:txBody>
+                  <a:tcPr marL="128016" marR="128016" marT="54864" marB="54864">
+                    <a:solidFill>
+                      <a:srgbClr val="EEF0FF"/>
+                    </a:solidFill>
+                  </a:tcPr>
+                </a:tc>
+                <a:tc>
+                  <a:txBody>
+                    <a:bodyPr wrap="square"/>
+                    <a:lstStyle/>
+                    <a:p>
+                      <a:pPr algn="l">
+                        <a:lnSpc>
+                          <a:spcPct val="105000"/>
+                        </a:lnSpc>
+                        <a:spcBef>
+                          <a:spcPts val="0"/>
+                        </a:spcBef>
+                        <a:spcAft>
+                          <a:spcPts val="0"/>
+                        </a:spcAft>
+                      </a:pPr>
+                      <a:r>
+                        <a:rPr sz="1100" b="0" i="0">
+                          <a:solidFill>
+                            <a:srgbClr val="2B2C4A"/>
+                          </a:solidFill>
+                          <a:latin typeface="Montserrat"/>
+                        </a:rPr>
+                        <a:t>Lesión mural fija; no cambia de posición.</a:t>
+                      </a:r>
+                    </a:p>
+                  </a:txBody>
+                  <a:tcPr marL="128016" marR="128016" marT="54864" marB="54864">
+                    <a:solidFill>
+                      <a:srgbClr val="EEF0FF"/>
+                    </a:solidFill>
+                  </a:tcPr>
+                </a:tc>
+                <a:tc>
+                  <a:txBody>
+                    <a:bodyPr wrap="square"/>
+                    <a:lstStyle/>
+                    <a:p>
+                      <a:pPr algn="l">
+                        <a:lnSpc>
+                          <a:spcPct val="105000"/>
+                        </a:lnSpc>
+                        <a:spcBef>
+                          <a:spcPts val="0"/>
+                        </a:spcBef>
+                        <a:spcAft>
+                          <a:spcPts val="0"/>
+                        </a:spcAft>
+                      </a:pPr>
+                      <a:r>
+                        <a:rPr sz="1100" b="0" i="0">
+                          <a:solidFill>
+                            <a:srgbClr val="2B2C4A"/>
+                          </a:solidFill>
+                          <a:latin typeface="Montserrat"/>
+                        </a:rPr>
+                        <a:t>Habitualmente sin sombra posterior.</a:t>
+                      </a:r>
+                    </a:p>
+                  </a:txBody>
+                  <a:tcPr marL="128016" marR="128016" marT="54864" marB="54864">
+                    <a:solidFill>
+                      <a:srgbClr val="EEF0FF"/>
+                    </a:solidFill>
+                  </a:tcPr>
+                </a:tc>
+              </a:tr>
+            </a:tbl>
+          </a:graphicData>
+        </a:graphic>
+      </p:graphicFrame>
+      <p:sp>
+        <p:nvSpPr>
+          <p:cNvPr id="9" name="Rounded Rectangle 8"/>
+          <p:cNvSpPr/>
+          <p:nvPr/>
+        </p:nvSpPr>
+        <p:spPr>
+          <a:xfrm>
+            <a:off x="594360" y="5394959"/>
+            <a:ext cx="10972800" cy="530352"/>
+          </a:xfrm>
+          <a:prstGeom prst="roundRect">
+            <a:avLst>
+              <a:gd name="adj" fmla="val 4000"/>
+            </a:avLst>
+          </a:prstGeom>
+          <a:solidFill>
+            <a:srgbClr val="EEF0FF"/>
+          </a:solidFill>
+          <a:ln w="11430">
+            <a:solidFill>
+              <a:srgbClr val="D92A2B"/>
+            </a:solidFill>
+          </a:ln>
+          <a:effectLst/>
+        </p:spPr>
+        <p:style>
+          <a:lnRef idx="1">
+            <a:schemeClr val="accent1"/>
+          </a:lnRef>
+          <a:fillRef idx="3">
+            <a:schemeClr val="accent1"/>
+          </a:fillRef>
+          <a:effectRef idx="2">
+            <a:schemeClr val="accent1"/>
+          </a:effectRef>
+          <a:fontRef idx="minor">
+            <a:schemeClr val="lt1"/>
+          </a:fontRef>
+        </p:style>
+        <p:txBody>
+          <a:bodyPr rtlCol="0" anchor="ctr"/>
+          <a:lstStyle/>
+          <a:p>
+            <a:pPr algn="ctr"/>
+          </a:p>
+        </p:txBody>
+      </p:sp>
+      <p:sp>
+        <p:nvSpPr>
+          <p:cNvPr id="10" name="TextBox 9"/>
+          <p:cNvSpPr txBox="1"/>
+          <p:nvPr/>
+        </p:nvSpPr>
+        <p:spPr>
+          <a:xfrm>
+            <a:off x="822960" y="5440679"/>
+            <a:ext cx="10515600" cy="438912"/>
+          </a:xfrm>
+          <a:prstGeom prst="rect">
+            <a:avLst/>
+          </a:prstGeom>
+          <a:noFill/>
+        </p:spPr>
+        <p:txBody>
+          <a:bodyPr wrap="square" anchor="ctr" lIns="0" rIns="0" tIns="0" bIns="0">
+            <a:spAutoFit/>
+          </a:bodyPr>
+          <a:lstStyle/>
+          <a:p>
+            <a:pPr algn="l">
+              <a:lnSpc>
+                <a:spcPct val="108000"/>
+              </a:lnSpc>
+              <a:spcAft>
+                <a:spcPts val="300"/>
+              </a:spcAft>
+            </a:pPr>
+            <a:r>
+              <a:rPr sz="1150" b="1" i="0">
+                <a:solidFill>
+                  <a:srgbClr val="3854CC"/>
+                </a:solidFill>
+                <a:latin typeface="Montserrat"/>
+              </a:rPr>
+              <a:t>CONCLUSIÓN EDITORIAL:  El cálculo proyecta sombra; el pólipo es fijo y no proyecta sombra.</a:t>
+            </a:r>
+          </a:p>
+        </p:txBody>
+      </p:sp>
+      <p:sp>
+        <p:nvSpPr>
+          <p:cNvPr id="11" name="TextBox 10"/>
+          <p:cNvSpPr txBox="1"/>
+          <p:nvPr/>
+        </p:nvSpPr>
+        <p:spPr>
+          <a:xfrm>
+            <a:off x="594360" y="6016752"/>
+            <a:ext cx="10972800" cy="256032"/>
+          </a:xfrm>
+          <a:prstGeom prst="rect">
+            <a:avLst/>
+          </a:prstGeom>
+          <a:noFill/>
+        </p:spPr>
+        <p:txBody>
+          <a:bodyPr wrap="square" anchor="t" lIns="0" rIns="0" tIns="0" bIns="0">
+            <a:spAutoFit/>
+          </a:bodyPr>
+          <a:lstStyle/>
+          <a:p>
+            <a:pPr algn="l">
+              <a:lnSpc>
+                <a:spcPct val="108000"/>
+              </a:lnSpc>
+              <a:spcAft>
+                <a:spcPts val="300"/>
+              </a:spcAft>
+            </a:pPr>
+            <a:r>
+              <a:rPr sz="900" b="0" i="1">
+                <a:solidFill>
+                  <a:srgbClr val="606383"/>
+                </a:solidFill>
+                <a:latin typeface="Montserrat"/>
+              </a:rPr>
+              <a:t>Ayuno de 6–8 h; documentar planos longitudinal y transversal, posición y sombra acústica.</a:t>
             </a:r>
           </a:p>
         </p:txBody>

</xml_diff>

<commit_message>
Annex slide 13: ultrasound table + textbook-style ultrasound schematic
- tools/diagram_ecografia.py: generates assets/ecografia_vesicular_esquema.png
  (normal bile, stone with posterior shadow, sludge with level, fixed polyp).
  Didactic schematic, labelled as illustration, not clinical image.
- tools/annex_layout.py: post-build step that compacts the table and places the
  schematic on slide 13 (manifest -> studydeck all -> annex_layout).
- Lint PASS, 13 slides, contrast 0 violations.

Co-authored-by: arena-agent <297053741+arena-agent@users.noreply.github.com>
</commit_message>
<xml_diff>
--- a/entregas-es/pancreatitis-biliar/Pancreatitis_biliar_12_diapositivas_es.pptx
+++ b/entregas-es/pancreatitis-biliar/Pancreatitis_biliar_12_diapositivas_es.pptx
@@ -6950,8 +6950,8 @@
           <p:nvPr/>
         </p:nvGraphicFramePr>
         <p:xfrm>
-          <a:off x="594360" y="1463040"/>
-          <a:ext cx="10972799" cy="3749039"/>
+          <a:off x="594360" y="1417320"/>
+          <a:ext cx="10972799" cy="1828800"/>
         </p:xfrm>
         <a:graphic>
           <a:graphicData uri="http://schemas.openxmlformats.org/drawingml/2006/table">
@@ -6964,7 +6964,7 @@
                 <a:gridCol w="4754880"/>
                 <a:gridCol w="3657600"/>
               </a:tblGrid>
-              <a:tr h="749807">
+              <a:tr h="365760">
                 <a:tc>
                   <a:txBody>
                     <a:bodyPr wrap="square"/>
@@ -7065,7 +7065,7 @@
                   </a:tcPr>
                 </a:tc>
               </a:tr>
-              <a:tr h="749807">
+              <a:tr h="365760">
                 <a:tc>
                   <a:txBody>
                     <a:bodyPr wrap="square"/>
@@ -7166,7 +7166,7 @@
                   </a:tcPr>
                 </a:tc>
               </a:tr>
-              <a:tr h="749807">
+              <a:tr h="365760">
                 <a:tc>
                   <a:txBody>
                     <a:bodyPr wrap="square"/>
@@ -7267,7 +7267,7 @@
                   </a:tcPr>
                 </a:tc>
               </a:tr>
-              <a:tr h="749807">
+              <a:tr h="365760">
                 <a:tc>
                   <a:txBody>
                     <a:bodyPr wrap="square"/>
@@ -7368,7 +7368,7 @@
                   </a:tcPr>
                 </a:tc>
               </a:tr>
-              <a:tr h="749811">
+              <a:tr h="365760">
                 <a:tc>
                   <a:txBody>
                     <a:bodyPr wrap="square"/>
@@ -7605,6 +7605,30 @@
           </a:p>
         </p:txBody>
       </p:sp>
+      <p:pic>
+        <p:nvPicPr>
+          <p:cNvPr id="12" name="Esquema didáctico de ecografía vesicular" descr="Esquema didáctico de ecografía vesicular: bilis normal anecoica, cálculo hiperecogénico con sombra acústica posterior, barro biliar con nivel y ecos bajos, y pólipo fijo sin sombra. Ilustración, no imagen clínica."/>
+          <p:cNvPicPr>
+            <a:picLocks noChangeAspect="1"/>
+          </p:cNvPicPr>
+          <p:nvPr/>
+        </p:nvPicPr>
+        <p:blipFill>
+          <a:blip r:embed="rId2"/>
+          <a:stretch>
+            <a:fillRect/>
+          </a:stretch>
+        </p:blipFill>
+        <p:spPr>
+          <a:xfrm>
+            <a:off x="594360" y="3383280"/>
+            <a:ext cx="10972800" cy="1874519"/>
+          </a:xfrm>
+          <a:prstGeom prst="rect">
+            <a:avLst/>
+          </a:prstGeom>
+        </p:spPr>
+      </p:pic>
     </p:spTree>
   </p:cSld>
   <p:clrMapOvr>

</xml_diff>

<commit_message>
Anexos 14-16: ilustraciones por código (colocalización acinar, Ringer vs SF, histología comparativa)
- tools/diagramas_anexo.py (v2): geometría corregida y redacción de hipótesis.
- assets/anexo_*.png regenerados.
- manifest.py: diapositivas 14-16 (module figure); IMAGES.max_n fijado en 6 por el autor.
- PPTX reconstruido: 16 diapositivas, 0 violaciones de contraste.

Co-authored-by: arena-agent <297053741+arena-agent@users.noreply.github.com>
</commit_message>
<xml_diff>
--- a/entregas-es/pancreatitis-biliar/Pancreatitis_biliar_12_diapositivas_es.pptx
+++ b/entregas-es/pancreatitis-biliar/Pancreatitis_biliar_12_diapositivas_es.pptx
@@ -18,6 +18,9 @@
     <p:sldId id="266" r:id="rId17"/>
     <p:sldId id="267" r:id="rId18"/>
     <p:sldId id="268" r:id="rId19"/>
+    <p:sldId id="269" r:id="rId20"/>
+    <p:sldId id="270" r:id="rId21"/>
+    <p:sldId id="271" r:id="rId22"/>
   </p:sldIdLst>
   <p:sldSz cx="12191695" cy="6858000" type="screen4x3"/>
   <p:notesSz cx="6858000" cy="9144000"/>
@@ -7637,6 +7640,1296 @@
 </p:sld>
 </file>
 
+<file path=ppt/slides/slide14.xml><?xml version="1.0" encoding="utf-8"?>
+<p:sld xmlns:a="http://schemas.openxmlformats.org/drawingml/2006/main" xmlns:p="http://schemas.openxmlformats.org/presentationml/2006/main" xmlns:r="http://schemas.openxmlformats.org/officeDocument/2006/relationships">
+  <p:cSld>
+    <p:spTree>
+      <p:nvGrpSpPr>
+        <p:cNvPr id="1" name=""/>
+        <p:cNvGrpSpPr/>
+        <p:nvPr/>
+      </p:nvGrpSpPr>
+      <p:grpSpPr/>
+      <p:sp>
+        <p:nvSpPr>
+          <p:cNvPr id="2" name="TextBox 1"/>
+          <p:cNvSpPr txBox="1"/>
+          <p:nvPr/>
+        </p:nvSpPr>
+        <p:spPr>
+          <a:xfrm>
+            <a:off x="594360" y="292608"/>
+            <a:ext cx="10058400" cy="219456"/>
+          </a:xfrm>
+          <a:prstGeom prst="rect">
+            <a:avLst/>
+          </a:prstGeom>
+          <a:noFill/>
+        </p:spPr>
+        <p:txBody>
+          <a:bodyPr wrap="square" anchor="t" lIns="0" rIns="0" tIns="0" bIns="0">
+            <a:spAutoFit/>
+          </a:bodyPr>
+          <a:lstStyle/>
+          <a:p>
+            <a:pPr algn="l">
+              <a:lnSpc>
+                <a:spcPct val="108000"/>
+              </a:lnSpc>
+              <a:spcAft>
+                <a:spcPts val="300"/>
+              </a:spcAft>
+            </a:pPr>
+            <a:r>
+              <a:rPr sz="950" b="1" i="0">
+                <a:solidFill>
+                  <a:srgbClr val="CA2728"/>
+                </a:solidFill>
+                <a:latin typeface="Montserrat"/>
+              </a:rPr>
+              <a:t>ANEXO · FISIOPATOLOGÍA</a:t>
+            </a:r>
+          </a:p>
+        </p:txBody>
+      </p:sp>
+      <p:sp>
+        <p:nvSpPr>
+          <p:cNvPr id="3" name="TextBox 2"/>
+          <p:cNvSpPr txBox="1"/>
+          <p:nvPr/>
+        </p:nvSpPr>
+        <p:spPr>
+          <a:xfrm>
+            <a:off x="594360" y="530352"/>
+            <a:ext cx="10972800" cy="594360"/>
+          </a:xfrm>
+          <a:prstGeom prst="rect">
+            <a:avLst/>
+          </a:prstGeom>
+          <a:noFill/>
+        </p:spPr>
+        <p:txBody>
+          <a:bodyPr wrap="square" anchor="t" lIns="0" rIns="0" tIns="0" bIns="0">
+            <a:spAutoFit/>
+          </a:bodyPr>
+          <a:lstStyle/>
+          <a:p>
+            <a:pPr algn="l">
+              <a:lnSpc>
+                <a:spcPct val="108000"/>
+              </a:lnSpc>
+              <a:spcAft>
+                <a:spcPts val="300"/>
+              </a:spcAft>
+            </a:pPr>
+            <a:r>
+              <a:rPr sz="2300" b="1" i="0">
+                <a:solidFill>
+                  <a:srgbClr val="3854CC"/>
+                </a:solidFill>
+                <a:latin typeface="Montserrat"/>
+              </a:rPr>
+              <a:t>Colocalización acinar y activación del tripsinógeno</a:t>
+            </a:r>
+          </a:p>
+        </p:txBody>
+      </p:sp>
+      <p:sp>
+        <p:nvSpPr>
+          <p:cNvPr id="4" name="Rectangle 3"/>
+          <p:cNvSpPr/>
+          <p:nvPr/>
+        </p:nvSpPr>
+        <p:spPr>
+          <a:xfrm>
+            <a:off x="594360" y="1170432"/>
+            <a:ext cx="1188720" cy="27432"/>
+          </a:xfrm>
+          <a:prstGeom prst="rect">
+            <a:avLst/>
+          </a:prstGeom>
+          <a:solidFill>
+            <a:srgbClr val="D92A2B"/>
+          </a:solidFill>
+          <a:ln>
+            <a:noFill/>
+          </a:ln>
+          <a:effectLst/>
+        </p:spPr>
+        <p:style>
+          <a:lnRef idx="1">
+            <a:schemeClr val="accent1"/>
+          </a:lnRef>
+          <a:fillRef idx="3">
+            <a:schemeClr val="accent1"/>
+          </a:fillRef>
+          <a:effectRef idx="2">
+            <a:schemeClr val="accent1"/>
+          </a:effectRef>
+          <a:fontRef idx="minor">
+            <a:schemeClr val="lt1"/>
+          </a:fontRef>
+        </p:style>
+        <p:txBody>
+          <a:bodyPr rtlCol="0" anchor="ctr"/>
+          <a:lstStyle/>
+          <a:p>
+            <a:pPr algn="ctr"/>
+          </a:p>
+        </p:txBody>
+      </p:sp>
+      <p:sp>
+        <p:nvSpPr>
+          <p:cNvPr id="5" name="Rectangle 4"/>
+          <p:cNvSpPr/>
+          <p:nvPr/>
+        </p:nvSpPr>
+        <p:spPr>
+          <a:xfrm>
+            <a:off x="1810512" y="1179576"/>
+            <a:ext cx="9784080" cy="9144"/>
+          </a:xfrm>
+          <a:prstGeom prst="rect">
+            <a:avLst/>
+          </a:prstGeom>
+          <a:solidFill>
+            <a:srgbClr val="D9DDF2"/>
+          </a:solidFill>
+          <a:ln>
+            <a:noFill/>
+          </a:ln>
+          <a:effectLst/>
+        </p:spPr>
+        <p:style>
+          <a:lnRef idx="1">
+            <a:schemeClr val="accent1"/>
+          </a:lnRef>
+          <a:fillRef idx="3">
+            <a:schemeClr val="accent1"/>
+          </a:fillRef>
+          <a:effectRef idx="2">
+            <a:schemeClr val="accent1"/>
+          </a:effectRef>
+          <a:fontRef idx="minor">
+            <a:schemeClr val="lt1"/>
+          </a:fontRef>
+        </p:style>
+        <p:txBody>
+          <a:bodyPr rtlCol="0" anchor="ctr"/>
+          <a:lstStyle/>
+          <a:p>
+            <a:pPr algn="ctr"/>
+          </a:p>
+        </p:txBody>
+      </p:sp>
+      <p:sp>
+        <p:nvSpPr>
+          <p:cNvPr id="6" name="TextBox 5"/>
+          <p:cNvSpPr txBox="1"/>
+          <p:nvPr/>
+        </p:nvSpPr>
+        <p:spPr>
+          <a:xfrm>
+            <a:off x="594360" y="6382512"/>
+            <a:ext cx="7772400" cy="256032"/>
+          </a:xfrm>
+          <a:prstGeom prst="rect">
+            <a:avLst/>
+          </a:prstGeom>
+          <a:noFill/>
+        </p:spPr>
+        <p:txBody>
+          <a:bodyPr wrap="square" anchor="t" lIns="0" rIns="0" tIns="0" bIns="0">
+            <a:spAutoFit/>
+          </a:bodyPr>
+          <a:lstStyle/>
+          <a:p>
+            <a:pPr algn="l">
+              <a:lnSpc>
+                <a:spcPct val="108000"/>
+              </a:lnSpc>
+              <a:spcAft>
+                <a:spcPts val="300"/>
+              </a:spcAft>
+            </a:pPr>
+            <a:r>
+              <a:rPr sz="900" b="0" i="0">
+                <a:solidFill>
+                  <a:srgbClr val="606383"/>
+                </a:solidFill>
+                <a:latin typeface="Montserrat"/>
+              </a:rPr>
+              <a:t>UNIVERSIDAD CENTRAL DEL PARAGUAY (UCP) · CARRERA DE MEDICINA</a:t>
+            </a:r>
+          </a:p>
+        </p:txBody>
+      </p:sp>
+      <p:sp>
+        <p:nvSpPr>
+          <p:cNvPr id="7" name="TextBox 6"/>
+          <p:cNvSpPr txBox="1"/>
+          <p:nvPr/>
+        </p:nvSpPr>
+        <p:spPr>
+          <a:xfrm>
+            <a:off x="10789920" y="6382512"/>
+            <a:ext cx="822960" cy="256032"/>
+          </a:xfrm>
+          <a:prstGeom prst="rect">
+            <a:avLst/>
+          </a:prstGeom>
+          <a:noFill/>
+        </p:spPr>
+        <p:txBody>
+          <a:bodyPr wrap="square" anchor="t" lIns="0" rIns="0" tIns="0" bIns="0">
+            <a:spAutoFit/>
+          </a:bodyPr>
+          <a:lstStyle/>
+          <a:p>
+            <a:pPr algn="r">
+              <a:lnSpc>
+                <a:spcPct val="108000"/>
+              </a:lnSpc>
+              <a:spcAft>
+                <a:spcPts val="300"/>
+              </a:spcAft>
+            </a:pPr>
+            <a:r>
+              <a:rPr sz="900" b="1" i="0">
+                <a:solidFill>
+                  <a:srgbClr val="606383"/>
+                </a:solidFill>
+                <a:latin typeface="Montserrat"/>
+              </a:rPr>
+              <a:t>14</a:t>
+            </a:r>
+          </a:p>
+        </p:txBody>
+      </p:sp>
+      <p:sp>
+        <p:nvSpPr>
+          <p:cNvPr id="8" name="Rounded Rectangle 7"/>
+          <p:cNvSpPr/>
+          <p:nvPr/>
+        </p:nvSpPr>
+        <p:spPr>
+          <a:xfrm>
+            <a:off x="614934" y="1380744"/>
+            <a:ext cx="10931652" cy="4416552"/>
+          </a:xfrm>
+          <a:prstGeom prst="roundRect">
+            <a:avLst>
+              <a:gd name="adj" fmla="val 2000"/>
+            </a:avLst>
+          </a:prstGeom>
+          <a:solidFill>
+            <a:srgbClr val="FFFFFF"/>
+          </a:solidFill>
+          <a:ln w="9525">
+            <a:solidFill>
+              <a:srgbClr val="D9DDF2"/>
+            </a:solidFill>
+          </a:ln>
+          <a:effectLst/>
+        </p:spPr>
+        <p:style>
+          <a:lnRef idx="1">
+            <a:schemeClr val="accent1"/>
+          </a:lnRef>
+          <a:fillRef idx="3">
+            <a:schemeClr val="accent1"/>
+          </a:fillRef>
+          <a:effectRef idx="2">
+            <a:schemeClr val="accent1"/>
+          </a:effectRef>
+          <a:fontRef idx="minor">
+            <a:schemeClr val="lt1"/>
+          </a:fontRef>
+        </p:style>
+        <p:txBody>
+          <a:bodyPr rtlCol="0" anchor="ctr"/>
+          <a:lstStyle/>
+          <a:p>
+            <a:pPr algn="ctr"/>
+          </a:p>
+        </p:txBody>
+      </p:sp>
+      <p:pic>
+        <p:nvPicPr>
+          <p:cNvPr id="9" name="Picture 8" descr="anexo_acino_colocalizacion.png"/>
+          <p:cNvPicPr>
+            <a:picLocks noChangeAspect="1"/>
+          </p:cNvPicPr>
+          <p:nvPr/>
+        </p:nvPicPr>
+        <p:blipFill>
+          <a:blip r:embed="rId2"/>
+          <a:stretch>
+            <a:fillRect/>
+          </a:stretch>
+        </p:blipFill>
+        <p:spPr>
+          <a:xfrm>
+            <a:off x="651510" y="1417320"/>
+            <a:ext cx="10858500" cy="4343400"/>
+          </a:xfrm>
+          <a:prstGeom prst="rect">
+            <a:avLst/>
+          </a:prstGeom>
+        </p:spPr>
+      </p:pic>
+      <p:sp>
+        <p:nvSpPr>
+          <p:cNvPr id="10" name="TextBox 9"/>
+          <p:cNvSpPr txBox="1"/>
+          <p:nvPr/>
+        </p:nvSpPr>
+        <p:spPr>
+          <a:xfrm>
+            <a:off x="594360" y="5760720"/>
+            <a:ext cx="10972800" cy="256032"/>
+          </a:xfrm>
+          <a:prstGeom prst="rect">
+            <a:avLst/>
+          </a:prstGeom>
+          <a:noFill/>
+        </p:spPr>
+        <p:txBody>
+          <a:bodyPr wrap="square" anchor="t" lIns="0" rIns="0" tIns="0" bIns="0">
+            <a:spAutoFit/>
+          </a:bodyPr>
+          <a:lstStyle/>
+          <a:p>
+            <a:pPr algn="l">
+              <a:lnSpc>
+                <a:spcPct val="108000"/>
+              </a:lnSpc>
+              <a:spcAft>
+                <a:spcPts val="300"/>
+              </a:spcAft>
+            </a:pPr>
+            <a:r>
+              <a:rPr sz="1050" b="0" i="1">
+                <a:solidFill>
+                  <a:srgbClr val="2B2C4A"/>
+                </a:solidFill>
+                <a:latin typeface="Montserrat"/>
+              </a:rPr>
+              <a:t>Catepsina B activa el tripsinógeno dentro de vacuolas ácidas del acino.</a:t>
+            </a:r>
+          </a:p>
+        </p:txBody>
+      </p:sp>
+      <p:sp>
+        <p:nvSpPr>
+          <p:cNvPr id="11" name="TextBox 10"/>
+          <p:cNvSpPr txBox="1"/>
+          <p:nvPr/>
+        </p:nvSpPr>
+        <p:spPr>
+          <a:xfrm>
+            <a:off x="594360" y="6053328"/>
+            <a:ext cx="10972800" cy="256032"/>
+          </a:xfrm>
+          <a:prstGeom prst="rect">
+            <a:avLst/>
+          </a:prstGeom>
+          <a:noFill/>
+        </p:spPr>
+        <p:txBody>
+          <a:bodyPr wrap="square" anchor="t" lIns="0" rIns="0" tIns="0" bIns="0">
+            <a:spAutoFit/>
+          </a:bodyPr>
+          <a:lstStyle/>
+          <a:p>
+            <a:pPr algn="l">
+              <a:lnSpc>
+                <a:spcPct val="108000"/>
+              </a:lnSpc>
+              <a:spcAft>
+                <a:spcPts val="300"/>
+              </a:spcAft>
+            </a:pPr>
+            <a:r>
+              <a:rPr sz="900" b="0" i="1">
+                <a:solidFill>
+                  <a:srgbClr val="606383"/>
+                </a:solidFill>
+                <a:latin typeface="Montserrat"/>
+              </a:rPr>
+              <a:t>La activación ocurre en organelas ácidas, no en gránulos de cimógeno (revisión WJG, 2024).  •  Crédito: Esquema ilustrativo de código propio; no es imagen clínica.</a:t>
+            </a:r>
+          </a:p>
+        </p:txBody>
+      </p:sp>
+    </p:spTree>
+  </p:cSld>
+  <p:clrMapOvr>
+    <a:masterClrMapping/>
+  </p:clrMapOvr>
+</p:sld>
+</file>
+
+<file path=ppt/slides/slide15.xml><?xml version="1.0" encoding="utf-8"?>
+<p:sld xmlns:a="http://schemas.openxmlformats.org/drawingml/2006/main" xmlns:p="http://schemas.openxmlformats.org/presentationml/2006/main" xmlns:r="http://schemas.openxmlformats.org/officeDocument/2006/relationships">
+  <p:cSld>
+    <p:spTree>
+      <p:nvGrpSpPr>
+        <p:cNvPr id="1" name=""/>
+        <p:cNvGrpSpPr/>
+        <p:nvPr/>
+      </p:nvGrpSpPr>
+      <p:grpSpPr/>
+      <p:sp>
+        <p:nvSpPr>
+          <p:cNvPr id="2" name="TextBox 1"/>
+          <p:cNvSpPr txBox="1"/>
+          <p:nvPr/>
+        </p:nvSpPr>
+        <p:spPr>
+          <a:xfrm>
+            <a:off x="594360" y="292608"/>
+            <a:ext cx="10058400" cy="219456"/>
+          </a:xfrm>
+          <a:prstGeom prst="rect">
+            <a:avLst/>
+          </a:prstGeom>
+          <a:noFill/>
+        </p:spPr>
+        <p:txBody>
+          <a:bodyPr wrap="square" anchor="t" lIns="0" rIns="0" tIns="0" bIns="0">
+            <a:spAutoFit/>
+          </a:bodyPr>
+          <a:lstStyle/>
+          <a:p>
+            <a:pPr algn="l">
+              <a:lnSpc>
+                <a:spcPct val="108000"/>
+              </a:lnSpc>
+              <a:spcAft>
+                <a:spcPts val="300"/>
+              </a:spcAft>
+            </a:pPr>
+            <a:r>
+              <a:rPr sz="950" b="1" i="0">
+                <a:solidFill>
+                  <a:srgbClr val="CA2728"/>
+                </a:solidFill>
+                <a:latin typeface="Montserrat"/>
+              </a:rPr>
+              <a:t>ANEXO · FARMACOLOGÍA</a:t>
+            </a:r>
+          </a:p>
+        </p:txBody>
+      </p:sp>
+      <p:sp>
+        <p:nvSpPr>
+          <p:cNvPr id="3" name="TextBox 2"/>
+          <p:cNvSpPr txBox="1"/>
+          <p:nvPr/>
+        </p:nvSpPr>
+        <p:spPr>
+          <a:xfrm>
+            <a:off x="594360" y="530352"/>
+            <a:ext cx="10972800" cy="594360"/>
+          </a:xfrm>
+          <a:prstGeom prst="rect">
+            <a:avLst/>
+          </a:prstGeom>
+          <a:noFill/>
+        </p:spPr>
+        <p:txBody>
+          <a:bodyPr wrap="square" anchor="t" lIns="0" rIns="0" tIns="0" bIns="0">
+            <a:spAutoFit/>
+          </a:bodyPr>
+          <a:lstStyle/>
+          <a:p>
+            <a:pPr algn="l">
+              <a:lnSpc>
+                <a:spcPct val="108000"/>
+              </a:lnSpc>
+              <a:spcAft>
+                <a:spcPts val="300"/>
+              </a:spcAft>
+            </a:pPr>
+            <a:r>
+              <a:rPr sz="2300" b="1" i="0">
+                <a:solidFill>
+                  <a:srgbClr val="3854CC"/>
+                </a:solidFill>
+                <a:latin typeface="Montserrat"/>
+              </a:rPr>
+              <a:t>Ringer lactato frente a solución fisiológica 0,9 %</a:t>
+            </a:r>
+          </a:p>
+        </p:txBody>
+      </p:sp>
+      <p:sp>
+        <p:nvSpPr>
+          <p:cNvPr id="4" name="Rectangle 3"/>
+          <p:cNvSpPr/>
+          <p:nvPr/>
+        </p:nvSpPr>
+        <p:spPr>
+          <a:xfrm>
+            <a:off x="594360" y="1170432"/>
+            <a:ext cx="1188720" cy="27432"/>
+          </a:xfrm>
+          <a:prstGeom prst="rect">
+            <a:avLst/>
+          </a:prstGeom>
+          <a:solidFill>
+            <a:srgbClr val="D92A2B"/>
+          </a:solidFill>
+          <a:ln>
+            <a:noFill/>
+          </a:ln>
+          <a:effectLst/>
+        </p:spPr>
+        <p:style>
+          <a:lnRef idx="1">
+            <a:schemeClr val="accent1"/>
+          </a:lnRef>
+          <a:fillRef idx="3">
+            <a:schemeClr val="accent1"/>
+          </a:fillRef>
+          <a:effectRef idx="2">
+            <a:schemeClr val="accent1"/>
+          </a:effectRef>
+          <a:fontRef idx="minor">
+            <a:schemeClr val="lt1"/>
+          </a:fontRef>
+        </p:style>
+        <p:txBody>
+          <a:bodyPr rtlCol="0" anchor="ctr"/>
+          <a:lstStyle/>
+          <a:p>
+            <a:pPr algn="ctr"/>
+          </a:p>
+        </p:txBody>
+      </p:sp>
+      <p:sp>
+        <p:nvSpPr>
+          <p:cNvPr id="5" name="Rectangle 4"/>
+          <p:cNvSpPr/>
+          <p:nvPr/>
+        </p:nvSpPr>
+        <p:spPr>
+          <a:xfrm>
+            <a:off x="1810512" y="1179576"/>
+            <a:ext cx="9784080" cy="9144"/>
+          </a:xfrm>
+          <a:prstGeom prst="rect">
+            <a:avLst/>
+          </a:prstGeom>
+          <a:solidFill>
+            <a:srgbClr val="D9DDF2"/>
+          </a:solidFill>
+          <a:ln>
+            <a:noFill/>
+          </a:ln>
+          <a:effectLst/>
+        </p:spPr>
+        <p:style>
+          <a:lnRef idx="1">
+            <a:schemeClr val="accent1"/>
+          </a:lnRef>
+          <a:fillRef idx="3">
+            <a:schemeClr val="accent1"/>
+          </a:fillRef>
+          <a:effectRef idx="2">
+            <a:schemeClr val="accent1"/>
+          </a:effectRef>
+          <a:fontRef idx="minor">
+            <a:schemeClr val="lt1"/>
+          </a:fontRef>
+        </p:style>
+        <p:txBody>
+          <a:bodyPr rtlCol="0" anchor="ctr"/>
+          <a:lstStyle/>
+          <a:p>
+            <a:pPr algn="ctr"/>
+          </a:p>
+        </p:txBody>
+      </p:sp>
+      <p:sp>
+        <p:nvSpPr>
+          <p:cNvPr id="6" name="TextBox 5"/>
+          <p:cNvSpPr txBox="1"/>
+          <p:nvPr/>
+        </p:nvSpPr>
+        <p:spPr>
+          <a:xfrm>
+            <a:off x="594360" y="6382512"/>
+            <a:ext cx="7772400" cy="256032"/>
+          </a:xfrm>
+          <a:prstGeom prst="rect">
+            <a:avLst/>
+          </a:prstGeom>
+          <a:noFill/>
+        </p:spPr>
+        <p:txBody>
+          <a:bodyPr wrap="square" anchor="t" lIns="0" rIns="0" tIns="0" bIns="0">
+            <a:spAutoFit/>
+          </a:bodyPr>
+          <a:lstStyle/>
+          <a:p>
+            <a:pPr algn="l">
+              <a:lnSpc>
+                <a:spcPct val="108000"/>
+              </a:lnSpc>
+              <a:spcAft>
+                <a:spcPts val="300"/>
+              </a:spcAft>
+            </a:pPr>
+            <a:r>
+              <a:rPr sz="900" b="0" i="0">
+                <a:solidFill>
+                  <a:srgbClr val="606383"/>
+                </a:solidFill>
+                <a:latin typeface="Montserrat"/>
+              </a:rPr>
+              <a:t>UNIVERSIDAD CENTRAL DEL PARAGUAY (UCP) · CARRERA DE MEDICINA</a:t>
+            </a:r>
+          </a:p>
+        </p:txBody>
+      </p:sp>
+      <p:sp>
+        <p:nvSpPr>
+          <p:cNvPr id="7" name="TextBox 6"/>
+          <p:cNvSpPr txBox="1"/>
+          <p:nvPr/>
+        </p:nvSpPr>
+        <p:spPr>
+          <a:xfrm>
+            <a:off x="10789920" y="6382512"/>
+            <a:ext cx="822960" cy="256032"/>
+          </a:xfrm>
+          <a:prstGeom prst="rect">
+            <a:avLst/>
+          </a:prstGeom>
+          <a:noFill/>
+        </p:spPr>
+        <p:txBody>
+          <a:bodyPr wrap="square" anchor="t" lIns="0" rIns="0" tIns="0" bIns="0">
+            <a:spAutoFit/>
+          </a:bodyPr>
+          <a:lstStyle/>
+          <a:p>
+            <a:pPr algn="r">
+              <a:lnSpc>
+                <a:spcPct val="108000"/>
+              </a:lnSpc>
+              <a:spcAft>
+                <a:spcPts val="300"/>
+              </a:spcAft>
+            </a:pPr>
+            <a:r>
+              <a:rPr sz="900" b="1" i="0">
+                <a:solidFill>
+                  <a:srgbClr val="606383"/>
+                </a:solidFill>
+                <a:latin typeface="Montserrat"/>
+              </a:rPr>
+              <a:t>15</a:t>
+            </a:r>
+          </a:p>
+        </p:txBody>
+      </p:sp>
+      <p:sp>
+        <p:nvSpPr>
+          <p:cNvPr id="8" name="Rounded Rectangle 7"/>
+          <p:cNvSpPr/>
+          <p:nvPr/>
+        </p:nvSpPr>
+        <p:spPr>
+          <a:xfrm>
+            <a:off x="614934" y="1380744"/>
+            <a:ext cx="10931652" cy="4416552"/>
+          </a:xfrm>
+          <a:prstGeom prst="roundRect">
+            <a:avLst>
+              <a:gd name="adj" fmla="val 2000"/>
+            </a:avLst>
+          </a:prstGeom>
+          <a:solidFill>
+            <a:srgbClr val="FFFFFF"/>
+          </a:solidFill>
+          <a:ln w="9525">
+            <a:solidFill>
+              <a:srgbClr val="D9DDF2"/>
+            </a:solidFill>
+          </a:ln>
+          <a:effectLst/>
+        </p:spPr>
+        <p:style>
+          <a:lnRef idx="1">
+            <a:schemeClr val="accent1"/>
+          </a:lnRef>
+          <a:fillRef idx="3">
+            <a:schemeClr val="accent1"/>
+          </a:fillRef>
+          <a:effectRef idx="2">
+            <a:schemeClr val="accent1"/>
+          </a:effectRef>
+          <a:fontRef idx="minor">
+            <a:schemeClr val="lt1"/>
+          </a:fontRef>
+        </p:style>
+        <p:txBody>
+          <a:bodyPr rtlCol="0" anchor="ctr"/>
+          <a:lstStyle/>
+          <a:p>
+            <a:pPr algn="ctr"/>
+          </a:p>
+        </p:txBody>
+      </p:sp>
+      <p:pic>
+        <p:nvPicPr>
+          <p:cNvPr id="9" name="Picture 8" descr="anexo_ringer_vs_salina.png"/>
+          <p:cNvPicPr>
+            <a:picLocks noChangeAspect="1"/>
+          </p:cNvPicPr>
+          <p:nvPr/>
+        </p:nvPicPr>
+        <p:blipFill>
+          <a:blip r:embed="rId2"/>
+          <a:stretch>
+            <a:fillRect/>
+          </a:stretch>
+        </p:blipFill>
+        <p:spPr>
+          <a:xfrm>
+            <a:off x="651510" y="1417320"/>
+            <a:ext cx="10858500" cy="4343400"/>
+          </a:xfrm>
+          <a:prstGeom prst="rect">
+            <a:avLst/>
+          </a:prstGeom>
+        </p:spPr>
+      </p:pic>
+      <p:sp>
+        <p:nvSpPr>
+          <p:cNvPr id="10" name="TextBox 9"/>
+          <p:cNvSpPr txBox="1"/>
+          <p:nvPr/>
+        </p:nvSpPr>
+        <p:spPr>
+          <a:xfrm>
+            <a:off x="594360" y="5760720"/>
+            <a:ext cx="10972800" cy="256032"/>
+          </a:xfrm>
+          <a:prstGeom prst="rect">
+            <a:avLst/>
+          </a:prstGeom>
+          <a:noFill/>
+        </p:spPr>
+        <p:txBody>
+          <a:bodyPr wrap="square" anchor="t" lIns="0" rIns="0" tIns="0" bIns="0">
+            <a:spAutoFit/>
+          </a:bodyPr>
+          <a:lstStyle/>
+          <a:p>
+            <a:pPr algn="l">
+              <a:lnSpc>
+                <a:spcPct val="108000"/>
+              </a:lnSpc>
+              <a:spcAft>
+                <a:spcPts val="300"/>
+              </a:spcAft>
+            </a:pPr>
+            <a:r>
+              <a:rPr sz="1050" b="0" i="1">
+                <a:solidFill>
+                  <a:srgbClr val="2B2C4A"/>
+                </a:solidFill>
+                <a:latin typeface="Montserrat"/>
+              </a:rPr>
+              <a:t>El exceso de cloruro es una hipótesis de acidosis; el lactato se metaboliza a bicarbonato.</a:t>
+            </a:r>
+          </a:p>
+        </p:txBody>
+      </p:sp>
+      <p:sp>
+        <p:nvSpPr>
+          <p:cNvPr id="11" name="TextBox 10"/>
+          <p:cNvSpPr txBox="1"/>
+          <p:nvPr/>
+        </p:nvSpPr>
+        <p:spPr>
+          <a:xfrm>
+            <a:off x="594360" y="6053328"/>
+            <a:ext cx="10972800" cy="256032"/>
+          </a:xfrm>
+          <a:prstGeom prst="rect">
+            <a:avLst/>
+          </a:prstGeom>
+          <a:noFill/>
+        </p:spPr>
+        <p:txBody>
+          <a:bodyPr wrap="square" anchor="t" lIns="0" rIns="0" tIns="0" bIns="0">
+            <a:spAutoFit/>
+          </a:bodyPr>
+          <a:lstStyle/>
+          <a:p>
+            <a:pPr algn="l">
+              <a:lnSpc>
+                <a:spcPct val="108000"/>
+              </a:lnSpc>
+              <a:spcAft>
+                <a:spcPts val="300"/>
+              </a:spcAft>
+            </a:pPr>
+            <a:r>
+              <a:rPr sz="900" b="0" i="1">
+                <a:solidFill>
+                  <a:srgbClr val="606383"/>
+                </a:solidFill>
+                <a:latin typeface="Montserrat"/>
+              </a:rPr>
+              <a:t>Ringer lactato: pH cercano a 6,5, levemente ácido. Dosis según la diapositiva 10.  •  Crédito: Esquema ilustrativo de código propio; composiciones de referencia.</a:t>
+            </a:r>
+          </a:p>
+        </p:txBody>
+      </p:sp>
+    </p:spTree>
+  </p:cSld>
+  <p:clrMapOvr>
+    <a:masterClrMapping/>
+  </p:clrMapOvr>
+</p:sld>
+</file>
+
+<file path=ppt/slides/slide16.xml><?xml version="1.0" encoding="utf-8"?>
+<p:sld xmlns:a="http://schemas.openxmlformats.org/drawingml/2006/main" xmlns:p="http://schemas.openxmlformats.org/presentationml/2006/main" xmlns:r="http://schemas.openxmlformats.org/officeDocument/2006/relationships">
+  <p:cSld>
+    <p:spTree>
+      <p:nvGrpSpPr>
+        <p:cNvPr id="1" name=""/>
+        <p:cNvGrpSpPr/>
+        <p:nvPr/>
+      </p:nvGrpSpPr>
+      <p:grpSpPr/>
+      <p:sp>
+        <p:nvSpPr>
+          <p:cNvPr id="2" name="TextBox 1"/>
+          <p:cNvSpPr txBox="1"/>
+          <p:nvPr/>
+        </p:nvSpPr>
+        <p:spPr>
+          <a:xfrm>
+            <a:off x="594360" y="292608"/>
+            <a:ext cx="10058400" cy="219456"/>
+          </a:xfrm>
+          <a:prstGeom prst="rect">
+            <a:avLst/>
+          </a:prstGeom>
+          <a:noFill/>
+        </p:spPr>
+        <p:txBody>
+          <a:bodyPr wrap="square" anchor="t" lIns="0" rIns="0" tIns="0" bIns="0">
+            <a:spAutoFit/>
+          </a:bodyPr>
+          <a:lstStyle/>
+          <a:p>
+            <a:pPr algn="l">
+              <a:lnSpc>
+                <a:spcPct val="108000"/>
+              </a:lnSpc>
+              <a:spcAft>
+                <a:spcPts val="300"/>
+              </a:spcAft>
+            </a:pPr>
+            <a:r>
+              <a:rPr sz="950" b="1" i="0">
+                <a:solidFill>
+                  <a:srgbClr val="CA2728"/>
+                </a:solidFill>
+                <a:latin typeface="Montserrat"/>
+              </a:rPr>
+              <a:t>ANEXO · ANATOMÍA PATOLÓGICA</a:t>
+            </a:r>
+          </a:p>
+        </p:txBody>
+      </p:sp>
+      <p:sp>
+        <p:nvSpPr>
+          <p:cNvPr id="3" name="TextBox 2"/>
+          <p:cNvSpPr txBox="1"/>
+          <p:nvPr/>
+        </p:nvSpPr>
+        <p:spPr>
+          <a:xfrm>
+            <a:off x="594360" y="530352"/>
+            <a:ext cx="10972800" cy="594360"/>
+          </a:xfrm>
+          <a:prstGeom prst="rect">
+            <a:avLst/>
+          </a:prstGeom>
+          <a:noFill/>
+        </p:spPr>
+        <p:txBody>
+          <a:bodyPr wrap="square" anchor="t" lIns="0" rIns="0" tIns="0" bIns="0">
+            <a:spAutoFit/>
+          </a:bodyPr>
+          <a:lstStyle/>
+          <a:p>
+            <a:pPr algn="l">
+              <a:lnSpc>
+                <a:spcPct val="108000"/>
+              </a:lnSpc>
+              <a:spcAft>
+                <a:spcPts val="300"/>
+              </a:spcAft>
+            </a:pPr>
+            <a:r>
+              <a:rPr sz="2300" b="1" i="0">
+                <a:solidFill>
+                  <a:srgbClr val="3854CC"/>
+                </a:solidFill>
+                <a:latin typeface="Montserrat"/>
+              </a:rPr>
+              <a:t>Pancreatitis edematosa frente a necrohemorrágica</a:t>
+            </a:r>
+          </a:p>
+        </p:txBody>
+      </p:sp>
+      <p:sp>
+        <p:nvSpPr>
+          <p:cNvPr id="4" name="Rectangle 3"/>
+          <p:cNvSpPr/>
+          <p:nvPr/>
+        </p:nvSpPr>
+        <p:spPr>
+          <a:xfrm>
+            <a:off x="594360" y="1170432"/>
+            <a:ext cx="1188720" cy="27432"/>
+          </a:xfrm>
+          <a:prstGeom prst="rect">
+            <a:avLst/>
+          </a:prstGeom>
+          <a:solidFill>
+            <a:srgbClr val="D92A2B"/>
+          </a:solidFill>
+          <a:ln>
+            <a:noFill/>
+          </a:ln>
+          <a:effectLst/>
+        </p:spPr>
+        <p:style>
+          <a:lnRef idx="1">
+            <a:schemeClr val="accent1"/>
+          </a:lnRef>
+          <a:fillRef idx="3">
+            <a:schemeClr val="accent1"/>
+          </a:fillRef>
+          <a:effectRef idx="2">
+            <a:schemeClr val="accent1"/>
+          </a:effectRef>
+          <a:fontRef idx="minor">
+            <a:schemeClr val="lt1"/>
+          </a:fontRef>
+        </p:style>
+        <p:txBody>
+          <a:bodyPr rtlCol="0" anchor="ctr"/>
+          <a:lstStyle/>
+          <a:p>
+            <a:pPr algn="ctr"/>
+          </a:p>
+        </p:txBody>
+      </p:sp>
+      <p:sp>
+        <p:nvSpPr>
+          <p:cNvPr id="5" name="Rectangle 4"/>
+          <p:cNvSpPr/>
+          <p:nvPr/>
+        </p:nvSpPr>
+        <p:spPr>
+          <a:xfrm>
+            <a:off x="1810512" y="1179576"/>
+            <a:ext cx="9784080" cy="9144"/>
+          </a:xfrm>
+          <a:prstGeom prst="rect">
+            <a:avLst/>
+          </a:prstGeom>
+          <a:solidFill>
+            <a:srgbClr val="D9DDF2"/>
+          </a:solidFill>
+          <a:ln>
+            <a:noFill/>
+          </a:ln>
+          <a:effectLst/>
+        </p:spPr>
+        <p:style>
+          <a:lnRef idx="1">
+            <a:schemeClr val="accent1"/>
+          </a:lnRef>
+          <a:fillRef idx="3">
+            <a:schemeClr val="accent1"/>
+          </a:fillRef>
+          <a:effectRef idx="2">
+            <a:schemeClr val="accent1"/>
+          </a:effectRef>
+          <a:fontRef idx="minor">
+            <a:schemeClr val="lt1"/>
+          </a:fontRef>
+        </p:style>
+        <p:txBody>
+          <a:bodyPr rtlCol="0" anchor="ctr"/>
+          <a:lstStyle/>
+          <a:p>
+            <a:pPr algn="ctr"/>
+          </a:p>
+        </p:txBody>
+      </p:sp>
+      <p:sp>
+        <p:nvSpPr>
+          <p:cNvPr id="6" name="TextBox 5"/>
+          <p:cNvSpPr txBox="1"/>
+          <p:nvPr/>
+        </p:nvSpPr>
+        <p:spPr>
+          <a:xfrm>
+            <a:off x="594360" y="6382512"/>
+            <a:ext cx="7772400" cy="256032"/>
+          </a:xfrm>
+          <a:prstGeom prst="rect">
+            <a:avLst/>
+          </a:prstGeom>
+          <a:noFill/>
+        </p:spPr>
+        <p:txBody>
+          <a:bodyPr wrap="square" anchor="t" lIns="0" rIns="0" tIns="0" bIns="0">
+            <a:spAutoFit/>
+          </a:bodyPr>
+          <a:lstStyle/>
+          <a:p>
+            <a:pPr algn="l">
+              <a:lnSpc>
+                <a:spcPct val="108000"/>
+              </a:lnSpc>
+              <a:spcAft>
+                <a:spcPts val="300"/>
+              </a:spcAft>
+            </a:pPr>
+            <a:r>
+              <a:rPr sz="900" b="0" i="0">
+                <a:solidFill>
+                  <a:srgbClr val="606383"/>
+                </a:solidFill>
+                <a:latin typeface="Montserrat"/>
+              </a:rPr>
+              <a:t>UNIVERSIDAD CENTRAL DEL PARAGUAY (UCP) · CARRERA DE MEDICINA</a:t>
+            </a:r>
+          </a:p>
+        </p:txBody>
+      </p:sp>
+      <p:sp>
+        <p:nvSpPr>
+          <p:cNvPr id="7" name="TextBox 6"/>
+          <p:cNvSpPr txBox="1"/>
+          <p:nvPr/>
+        </p:nvSpPr>
+        <p:spPr>
+          <a:xfrm>
+            <a:off x="10789920" y="6382512"/>
+            <a:ext cx="822960" cy="256032"/>
+          </a:xfrm>
+          <a:prstGeom prst="rect">
+            <a:avLst/>
+          </a:prstGeom>
+          <a:noFill/>
+        </p:spPr>
+        <p:txBody>
+          <a:bodyPr wrap="square" anchor="t" lIns="0" rIns="0" tIns="0" bIns="0">
+            <a:spAutoFit/>
+          </a:bodyPr>
+          <a:lstStyle/>
+          <a:p>
+            <a:pPr algn="r">
+              <a:lnSpc>
+                <a:spcPct val="108000"/>
+              </a:lnSpc>
+              <a:spcAft>
+                <a:spcPts val="300"/>
+              </a:spcAft>
+            </a:pPr>
+            <a:r>
+              <a:rPr sz="900" b="1" i="0">
+                <a:solidFill>
+                  <a:srgbClr val="606383"/>
+                </a:solidFill>
+                <a:latin typeface="Montserrat"/>
+              </a:rPr>
+              <a:t>16</a:t>
+            </a:r>
+          </a:p>
+        </p:txBody>
+      </p:sp>
+      <p:sp>
+        <p:nvSpPr>
+          <p:cNvPr id="8" name="Rounded Rectangle 7"/>
+          <p:cNvSpPr/>
+          <p:nvPr/>
+        </p:nvSpPr>
+        <p:spPr>
+          <a:xfrm>
+            <a:off x="614934" y="1380744"/>
+            <a:ext cx="10931652" cy="4416552"/>
+          </a:xfrm>
+          <a:prstGeom prst="roundRect">
+            <a:avLst>
+              <a:gd name="adj" fmla="val 2000"/>
+            </a:avLst>
+          </a:prstGeom>
+          <a:solidFill>
+            <a:srgbClr val="FFFFFF"/>
+          </a:solidFill>
+          <a:ln w="9525">
+            <a:solidFill>
+              <a:srgbClr val="D9DDF2"/>
+            </a:solidFill>
+          </a:ln>
+          <a:effectLst/>
+        </p:spPr>
+        <p:style>
+          <a:lnRef idx="1">
+            <a:schemeClr val="accent1"/>
+          </a:lnRef>
+          <a:fillRef idx="3">
+            <a:schemeClr val="accent1"/>
+          </a:fillRef>
+          <a:effectRef idx="2">
+            <a:schemeClr val="accent1"/>
+          </a:effectRef>
+          <a:fontRef idx="minor">
+            <a:schemeClr val="lt1"/>
+          </a:fontRef>
+        </p:style>
+        <p:txBody>
+          <a:bodyPr rtlCol="0" anchor="ctr"/>
+          <a:lstStyle/>
+          <a:p>
+            <a:pPr algn="ctr"/>
+          </a:p>
+        </p:txBody>
+      </p:sp>
+      <p:pic>
+        <p:nvPicPr>
+          <p:cNvPr id="9" name="Picture 8" descr="anexo_histologia_comparativa.png"/>
+          <p:cNvPicPr>
+            <a:picLocks noChangeAspect="1"/>
+          </p:cNvPicPr>
+          <p:nvPr/>
+        </p:nvPicPr>
+        <p:blipFill>
+          <a:blip r:embed="rId2"/>
+          <a:stretch>
+            <a:fillRect/>
+          </a:stretch>
+        </p:blipFill>
+        <p:spPr>
+          <a:xfrm>
+            <a:off x="651510" y="1417320"/>
+            <a:ext cx="10858500" cy="4343400"/>
+          </a:xfrm>
+          <a:prstGeom prst="rect">
+            <a:avLst/>
+          </a:prstGeom>
+        </p:spPr>
+      </p:pic>
+      <p:sp>
+        <p:nvSpPr>
+          <p:cNvPr id="10" name="TextBox 9"/>
+          <p:cNvSpPr txBox="1"/>
+          <p:nvPr/>
+        </p:nvSpPr>
+        <p:spPr>
+          <a:xfrm>
+            <a:off x="594360" y="5760720"/>
+            <a:ext cx="10972800" cy="256032"/>
+          </a:xfrm>
+          <a:prstGeom prst="rect">
+            <a:avLst/>
+          </a:prstGeom>
+          <a:noFill/>
+        </p:spPr>
+        <p:txBody>
+          <a:bodyPr wrap="square" anchor="t" lIns="0" rIns="0" tIns="0" bIns="0">
+            <a:spAutoFit/>
+          </a:bodyPr>
+          <a:lstStyle/>
+          <a:p>
+            <a:pPr algn="l">
+              <a:lnSpc>
+                <a:spcPct val="108000"/>
+              </a:lnSpc>
+              <a:spcAft>
+                <a:spcPts val="300"/>
+              </a:spcAft>
+            </a:pPr>
+            <a:r>
+              <a:rPr sz="1050" b="0" i="1">
+                <a:solidFill>
+                  <a:srgbClr val="2B2C4A"/>
+                </a:solidFill>
+                <a:latin typeface="Montserrat"/>
+              </a:rPr>
+              <a:t>Edematosa: acinos viables y esteatonecrosis. Necrohemorrágica: destrucción y hemorragia.</a:t>
+            </a:r>
+          </a:p>
+        </p:txBody>
+      </p:sp>
+      <p:sp>
+        <p:nvSpPr>
+          <p:cNvPr id="11" name="TextBox 10"/>
+          <p:cNvSpPr txBox="1"/>
+          <p:nvPr/>
+        </p:nvSpPr>
+        <p:spPr>
+          <a:xfrm>
+            <a:off x="594360" y="6053328"/>
+            <a:ext cx="10972800" cy="256032"/>
+          </a:xfrm>
+          <a:prstGeom prst="rect">
+            <a:avLst/>
+          </a:prstGeom>
+          <a:noFill/>
+        </p:spPr>
+        <p:txBody>
+          <a:bodyPr wrap="square" anchor="t" lIns="0" rIns="0" tIns="0" bIns="0">
+            <a:spAutoFit/>
+          </a:bodyPr>
+          <a:lstStyle/>
+          <a:p>
+            <a:pPr algn="l">
+              <a:lnSpc>
+                <a:spcPct val="108000"/>
+              </a:lnSpc>
+              <a:spcAft>
+                <a:spcPts val="300"/>
+              </a:spcAft>
+            </a:pPr>
+            <a:r>
+              <a:rPr sz="900" b="0" i="1">
+                <a:solidFill>
+                  <a:srgbClr val="606383"/>
+                </a:solidFill>
+                <a:latin typeface="Montserrat"/>
+              </a:rPr>
+              <a:t>Comparación de arquitectura para la sabatina; la lámina real del caso sigue pendiente.  •  Crédito: Esquema ilustrativo de código propio; no es la lámina del Caso Clínico 09.</a:t>
+            </a:r>
+          </a:p>
+        </p:txBody>
+      </p:sp>
+    </p:spTree>
+  </p:cSld>
+  <p:clrMapOvr>
+    <a:masterClrMapping/>
+  </p:clrMapOvr>
+</p:sld>
+</file>
+
 <file path=ppt/slides/slide2.xml><?xml version="1.0" encoding="utf-8"?>
 <p:sld xmlns:a="http://schemas.openxmlformats.org/drawingml/2006/main" xmlns:p="http://schemas.openxmlformats.org/presentationml/2006/main" xmlns:r="http://schemas.openxmlformats.org/officeDocument/2006/relationships">
   <p:cSld>

</xml_diff>

<commit_message>
Anexo 17: vía del dolor pancreático (ilustración 3, por código)
- tools/diagramas_anexo.py: diagram_dolor() -> assets/anexo_via_dolor.png.
  Sin 'prece maometana'; 'irradiación posterior' en lugar de 'dolor en cinto'; aferencias T5-T9.
- manifest.py: diapositiva 17 (module figure); IMAGES.max_n fijado en 7 por decisión del autor.
- PPTX reconstruido: 17 diapositivas, 0 violaciones de contraste.

Co-authored-by: arena-agent <297053741+arena-agent@users.noreply.github.com>
</commit_message>
<xml_diff>
--- a/entregas-es/pancreatitis-biliar/Pancreatitis_biliar_12_diapositivas_es.pptx
+++ b/entregas-es/pancreatitis-biliar/Pancreatitis_biliar_12_diapositivas_es.pptx
@@ -21,6 +21,7 @@
     <p:sldId id="269" r:id="rId20"/>
     <p:sldId id="270" r:id="rId21"/>
     <p:sldId id="271" r:id="rId22"/>
+    <p:sldId id="272" r:id="rId23"/>
   </p:sldIdLst>
   <p:sldSz cx="12191695" cy="6858000" type="screen4x3"/>
   <p:notesSz cx="6858000" cy="9144000"/>
@@ -8930,6 +8931,436 @@
 </p:sld>
 </file>
 
+<file path=ppt/slides/slide17.xml><?xml version="1.0" encoding="utf-8"?>
+<p:sld xmlns:a="http://schemas.openxmlformats.org/drawingml/2006/main" xmlns:p="http://schemas.openxmlformats.org/presentationml/2006/main" xmlns:r="http://schemas.openxmlformats.org/officeDocument/2006/relationships">
+  <p:cSld>
+    <p:spTree>
+      <p:nvGrpSpPr>
+        <p:cNvPr id="1" name=""/>
+        <p:cNvGrpSpPr/>
+        <p:nvPr/>
+      </p:nvGrpSpPr>
+      <p:grpSpPr/>
+      <p:sp>
+        <p:nvSpPr>
+          <p:cNvPr id="2" name="TextBox 1"/>
+          <p:cNvSpPr txBox="1"/>
+          <p:nvPr/>
+        </p:nvSpPr>
+        <p:spPr>
+          <a:xfrm>
+            <a:off x="594360" y="292608"/>
+            <a:ext cx="10058400" cy="219456"/>
+          </a:xfrm>
+          <a:prstGeom prst="rect">
+            <a:avLst/>
+          </a:prstGeom>
+          <a:noFill/>
+        </p:spPr>
+        <p:txBody>
+          <a:bodyPr wrap="square" anchor="t" lIns="0" rIns="0" tIns="0" bIns="0">
+            <a:spAutoFit/>
+          </a:bodyPr>
+          <a:lstStyle/>
+          <a:p>
+            <a:pPr algn="l">
+              <a:lnSpc>
+                <a:spcPct val="108000"/>
+              </a:lnSpc>
+              <a:spcAft>
+                <a:spcPts val="300"/>
+              </a:spcAft>
+            </a:pPr>
+            <a:r>
+              <a:rPr sz="950" b="1" i="0">
+                <a:solidFill>
+                  <a:srgbClr val="CA2728"/>
+                </a:solidFill>
+                <a:latin typeface="Montserrat"/>
+              </a:rPr>
+              <a:t>ANEXO · FISIOLOGÍA DEL DOLOR</a:t>
+            </a:r>
+          </a:p>
+        </p:txBody>
+      </p:sp>
+      <p:sp>
+        <p:nvSpPr>
+          <p:cNvPr id="3" name="TextBox 2"/>
+          <p:cNvSpPr txBox="1"/>
+          <p:nvPr/>
+        </p:nvSpPr>
+        <p:spPr>
+          <a:xfrm>
+            <a:off x="594360" y="530352"/>
+            <a:ext cx="10972800" cy="594360"/>
+          </a:xfrm>
+          <a:prstGeom prst="rect">
+            <a:avLst/>
+          </a:prstGeom>
+          <a:noFill/>
+        </p:spPr>
+        <p:txBody>
+          <a:bodyPr wrap="square" anchor="t" lIns="0" rIns="0" tIns="0" bIns="0">
+            <a:spAutoFit/>
+          </a:bodyPr>
+          <a:lstStyle/>
+          <a:p>
+            <a:pPr algn="l">
+              <a:lnSpc>
+                <a:spcPct val="108000"/>
+              </a:lnSpc>
+              <a:spcAft>
+                <a:spcPts val="300"/>
+              </a:spcAft>
+            </a:pPr>
+            <a:r>
+              <a:rPr sz="2300" b="1" i="0">
+                <a:solidFill>
+                  <a:srgbClr val="3854CC"/>
+                </a:solidFill>
+                <a:latin typeface="Montserrat"/>
+              </a:rPr>
+              <a:t>Vía del dolor pancreático y su proyección</a:t>
+            </a:r>
+          </a:p>
+        </p:txBody>
+      </p:sp>
+      <p:sp>
+        <p:nvSpPr>
+          <p:cNvPr id="4" name="Rectangle 3"/>
+          <p:cNvSpPr/>
+          <p:nvPr/>
+        </p:nvSpPr>
+        <p:spPr>
+          <a:xfrm>
+            <a:off x="594360" y="1170432"/>
+            <a:ext cx="1188720" cy="27432"/>
+          </a:xfrm>
+          <a:prstGeom prst="rect">
+            <a:avLst/>
+          </a:prstGeom>
+          <a:solidFill>
+            <a:srgbClr val="D92A2B"/>
+          </a:solidFill>
+          <a:ln>
+            <a:noFill/>
+          </a:ln>
+          <a:effectLst/>
+        </p:spPr>
+        <p:style>
+          <a:lnRef idx="1">
+            <a:schemeClr val="accent1"/>
+          </a:lnRef>
+          <a:fillRef idx="3">
+            <a:schemeClr val="accent1"/>
+          </a:fillRef>
+          <a:effectRef idx="2">
+            <a:schemeClr val="accent1"/>
+          </a:effectRef>
+          <a:fontRef idx="minor">
+            <a:schemeClr val="lt1"/>
+          </a:fontRef>
+        </p:style>
+        <p:txBody>
+          <a:bodyPr rtlCol="0" anchor="ctr"/>
+          <a:lstStyle/>
+          <a:p>
+            <a:pPr algn="ctr"/>
+          </a:p>
+        </p:txBody>
+      </p:sp>
+      <p:sp>
+        <p:nvSpPr>
+          <p:cNvPr id="5" name="Rectangle 4"/>
+          <p:cNvSpPr/>
+          <p:nvPr/>
+        </p:nvSpPr>
+        <p:spPr>
+          <a:xfrm>
+            <a:off x="1810512" y="1179576"/>
+            <a:ext cx="9784080" cy="9144"/>
+          </a:xfrm>
+          <a:prstGeom prst="rect">
+            <a:avLst/>
+          </a:prstGeom>
+          <a:solidFill>
+            <a:srgbClr val="D9DDF2"/>
+          </a:solidFill>
+          <a:ln>
+            <a:noFill/>
+          </a:ln>
+          <a:effectLst/>
+        </p:spPr>
+        <p:style>
+          <a:lnRef idx="1">
+            <a:schemeClr val="accent1"/>
+          </a:lnRef>
+          <a:fillRef idx="3">
+            <a:schemeClr val="accent1"/>
+          </a:fillRef>
+          <a:effectRef idx="2">
+            <a:schemeClr val="accent1"/>
+          </a:effectRef>
+          <a:fontRef idx="minor">
+            <a:schemeClr val="lt1"/>
+          </a:fontRef>
+        </p:style>
+        <p:txBody>
+          <a:bodyPr rtlCol="0" anchor="ctr"/>
+          <a:lstStyle/>
+          <a:p>
+            <a:pPr algn="ctr"/>
+          </a:p>
+        </p:txBody>
+      </p:sp>
+      <p:sp>
+        <p:nvSpPr>
+          <p:cNvPr id="6" name="TextBox 5"/>
+          <p:cNvSpPr txBox="1"/>
+          <p:nvPr/>
+        </p:nvSpPr>
+        <p:spPr>
+          <a:xfrm>
+            <a:off x="594360" y="6382512"/>
+            <a:ext cx="7772400" cy="256032"/>
+          </a:xfrm>
+          <a:prstGeom prst="rect">
+            <a:avLst/>
+          </a:prstGeom>
+          <a:noFill/>
+        </p:spPr>
+        <p:txBody>
+          <a:bodyPr wrap="square" anchor="t" lIns="0" rIns="0" tIns="0" bIns="0">
+            <a:spAutoFit/>
+          </a:bodyPr>
+          <a:lstStyle/>
+          <a:p>
+            <a:pPr algn="l">
+              <a:lnSpc>
+                <a:spcPct val="108000"/>
+              </a:lnSpc>
+              <a:spcAft>
+                <a:spcPts val="300"/>
+              </a:spcAft>
+            </a:pPr>
+            <a:r>
+              <a:rPr sz="900" b="0" i="0">
+                <a:solidFill>
+                  <a:srgbClr val="606383"/>
+                </a:solidFill>
+                <a:latin typeface="Montserrat"/>
+              </a:rPr>
+              <a:t>UNIVERSIDAD CENTRAL DEL PARAGUAY (UCP) · CARRERA DE MEDICINA</a:t>
+            </a:r>
+          </a:p>
+        </p:txBody>
+      </p:sp>
+      <p:sp>
+        <p:nvSpPr>
+          <p:cNvPr id="7" name="TextBox 6"/>
+          <p:cNvSpPr txBox="1"/>
+          <p:nvPr/>
+        </p:nvSpPr>
+        <p:spPr>
+          <a:xfrm>
+            <a:off x="10789920" y="6382512"/>
+            <a:ext cx="822960" cy="256032"/>
+          </a:xfrm>
+          <a:prstGeom prst="rect">
+            <a:avLst/>
+          </a:prstGeom>
+          <a:noFill/>
+        </p:spPr>
+        <p:txBody>
+          <a:bodyPr wrap="square" anchor="t" lIns="0" rIns="0" tIns="0" bIns="0">
+            <a:spAutoFit/>
+          </a:bodyPr>
+          <a:lstStyle/>
+          <a:p>
+            <a:pPr algn="r">
+              <a:lnSpc>
+                <a:spcPct val="108000"/>
+              </a:lnSpc>
+              <a:spcAft>
+                <a:spcPts val="300"/>
+              </a:spcAft>
+            </a:pPr>
+            <a:r>
+              <a:rPr sz="900" b="1" i="0">
+                <a:solidFill>
+                  <a:srgbClr val="606383"/>
+                </a:solidFill>
+                <a:latin typeface="Montserrat"/>
+              </a:rPr>
+              <a:t>17</a:t>
+            </a:r>
+          </a:p>
+        </p:txBody>
+      </p:sp>
+      <p:sp>
+        <p:nvSpPr>
+          <p:cNvPr id="8" name="Rounded Rectangle 7"/>
+          <p:cNvSpPr/>
+          <p:nvPr/>
+        </p:nvSpPr>
+        <p:spPr>
+          <a:xfrm>
+            <a:off x="614934" y="1380744"/>
+            <a:ext cx="10931652" cy="4416552"/>
+          </a:xfrm>
+          <a:prstGeom prst="roundRect">
+            <a:avLst>
+              <a:gd name="adj" fmla="val 2000"/>
+            </a:avLst>
+          </a:prstGeom>
+          <a:solidFill>
+            <a:srgbClr val="FFFFFF"/>
+          </a:solidFill>
+          <a:ln w="9525">
+            <a:solidFill>
+              <a:srgbClr val="D9DDF2"/>
+            </a:solidFill>
+          </a:ln>
+          <a:effectLst/>
+        </p:spPr>
+        <p:style>
+          <a:lnRef idx="1">
+            <a:schemeClr val="accent1"/>
+          </a:lnRef>
+          <a:fillRef idx="3">
+            <a:schemeClr val="accent1"/>
+          </a:fillRef>
+          <a:effectRef idx="2">
+            <a:schemeClr val="accent1"/>
+          </a:effectRef>
+          <a:fontRef idx="minor">
+            <a:schemeClr val="lt1"/>
+          </a:fontRef>
+        </p:style>
+        <p:txBody>
+          <a:bodyPr rtlCol="0" anchor="ctr"/>
+          <a:lstStyle/>
+          <a:p>
+            <a:pPr algn="ctr"/>
+          </a:p>
+        </p:txBody>
+      </p:sp>
+      <p:pic>
+        <p:nvPicPr>
+          <p:cNvPr id="9" name="Picture 8" descr="anexo_via_dolor.png"/>
+          <p:cNvPicPr>
+            <a:picLocks noChangeAspect="1"/>
+          </p:cNvPicPr>
+          <p:nvPr/>
+        </p:nvPicPr>
+        <p:blipFill>
+          <a:blip r:embed="rId2"/>
+          <a:stretch>
+            <a:fillRect/>
+          </a:stretch>
+        </p:blipFill>
+        <p:spPr>
+          <a:xfrm>
+            <a:off x="651510" y="1417320"/>
+            <a:ext cx="10858500" cy="4343400"/>
+          </a:xfrm>
+          <a:prstGeom prst="rect">
+            <a:avLst/>
+          </a:prstGeom>
+        </p:spPr>
+      </p:pic>
+      <p:sp>
+        <p:nvSpPr>
+          <p:cNvPr id="10" name="TextBox 9"/>
+          <p:cNvSpPr txBox="1"/>
+          <p:nvPr/>
+        </p:nvSpPr>
+        <p:spPr>
+          <a:xfrm>
+            <a:off x="594360" y="5760720"/>
+            <a:ext cx="10972800" cy="256032"/>
+          </a:xfrm>
+          <a:prstGeom prst="rect">
+            <a:avLst/>
+          </a:prstGeom>
+          <a:noFill/>
+        </p:spPr>
+        <p:txBody>
+          <a:bodyPr wrap="square" anchor="t" lIns="0" rIns="0" tIns="0" bIns="0">
+            <a:spAutoFit/>
+          </a:bodyPr>
+          <a:lstStyle/>
+          <a:p>
+            <a:pPr algn="l">
+              <a:lnSpc>
+                <a:spcPct val="108000"/>
+              </a:lnSpc>
+              <a:spcAft>
+                <a:spcPts val="300"/>
+              </a:spcAft>
+            </a:pPr>
+            <a:r>
+              <a:rPr sz="1050" b="0" i="1">
+                <a:solidFill>
+                  <a:srgbClr val="2B2C4A"/>
+                </a:solidFill>
+                <a:latin typeface="Montserrat"/>
+              </a:rPr>
+              <a:t>El dolor pancreático viaja por aferencias T5–T9 y se proyecta al epigastrio y a la espalda.</a:t>
+            </a:r>
+          </a:p>
+        </p:txBody>
+      </p:sp>
+      <p:sp>
+        <p:nvSpPr>
+          <p:cNvPr id="11" name="TextBox 10"/>
+          <p:cNvSpPr txBox="1"/>
+          <p:nvPr/>
+        </p:nvSpPr>
+        <p:spPr>
+          <a:xfrm>
+            <a:off x="594360" y="6053328"/>
+            <a:ext cx="10972800" cy="256032"/>
+          </a:xfrm>
+          <a:prstGeom prst="rect">
+            <a:avLst/>
+          </a:prstGeom>
+          <a:noFill/>
+        </p:spPr>
+        <p:txBody>
+          <a:bodyPr wrap="square" anchor="t" lIns="0" rIns="0" tIns="0" bIns="0">
+            <a:spAutoFit/>
+          </a:bodyPr>
+          <a:lstStyle/>
+          <a:p>
+            <a:pPr algn="l">
+              <a:lnSpc>
+                <a:spcPct val="108000"/>
+              </a:lnSpc>
+              <a:spcAft>
+                <a:spcPts val="300"/>
+              </a:spcAft>
+            </a:pPr>
+            <a:r>
+              <a:rPr sz="900" b="0" i="1">
+                <a:solidFill>
+                  <a:srgbClr val="606383"/>
+                </a:solidFill>
+                <a:latin typeface="Montserrat"/>
+              </a:rPr>
+              <a:t>La irradiación posterior sigue el mismo territorio metamérico que las aferencias pancreáticas (T5–T9).  •  Crédito: Esquema ilustrativo de código propio; vía simplificada, no imagen clínica.</a:t>
+            </a:r>
+          </a:p>
+        </p:txBody>
+      </p:sp>
+    </p:spTree>
+  </p:cSld>
+  <p:clrMapOvr>
+    <a:masterClrMapping/>
+  </p:clrMapOvr>
+</p:sld>
+</file>
+
 <file path=ppt/slides/slide2.xml><?xml version="1.0" encoding="utf-8"?>
 <p:sld xmlns:a="http://schemas.openxmlformats.org/drawingml/2006/main" xmlns:p="http://schemas.openxmlformats.org/presentationml/2006/main" xmlns:r="http://schemas.openxmlformats.org/officeDocument/2006/relationships">
   <p:cSld>

</xml_diff>

<commit_message>
Correcciones tras verificación de fuentes (PONCHO, ventana TC, referencias)
- Diap. 11: '30 % a 90 días' sustituido por el dato del PONCHO (Lancet 2015): 17 % vs 5 % a 6 meses.
- Diap. 9: takeaway de TC 72-96 h reformulado a 'reduce el riesgo de subestimar la necrosis'.
- Diap. 12: añadida WSES 2019 (Leppäniemi A et al., World J Emerg Surg 2019;14:27) como fuente de la ventana TC.
- PPTX reconstruido: 17 diapositivas, 0 violaciones de contraste.

Co-authored-by: arena-agent <297053741+arena-agent@users.noreply.github.com>
</commit_message>
<xml_diff>
--- a/entregas-es/pancreatitis-biliar/Pancreatitis_biliar_12_diapositivas_es.pptx
+++ b/entregas-es/pancreatitis-biliar/Pancreatitis_biliar_12_diapositivas_es.pptx
@@ -5174,7 +5174,7 @@
                 </a:solidFill>
                 <a:latin typeface="Montserrat"/>
               </a:rPr>
-              <a:t>Tras remitir la clínica aguda (PONCHO). Previene la recidiva biliar: 30 % a 90 días sin cirugía.</a:t>
+              <a:t>PONCHO, 6 meses: reingreso o muerte por litiasis, 17 % con cirugía diferida frente a 5 % en el mismo ingreso.</a:t>
             </a:r>
           </a:p>
         </p:txBody>
@@ -6120,7 +6120,7 @@
                 </a:solidFill>
                 <a:latin typeface="Montserrat"/>
               </a:rPr>
-              <a:t>REFERENCIAS · 6</a:t>
+              <a:t>REFERENCIAS · 7</a:t>
             </a:r>
           </a:p>
         </p:txBody>
@@ -6288,7 +6288,7 @@
                 </a:solidFill>
                 <a:latin typeface="Montserrat"/>
               </a:rPr>
-              <a:t>Tenner S, et al. American College of Gastroenterology Guideline: Management of Acute Pancreatitis. Am J Gastroenterol. 2024;119(3):419-437.</a:t>
+              <a:t>Leppäniemi A, Tolonen M, Tarasconi A, et al. 2019 WSES guidelines for the management of severe acute pancreatitis. World J Emerg Surg. 2019;14:27.</a:t>
             </a:r>
           </a:p>
         </p:txBody>
@@ -6372,7 +6372,7 @@
                 </a:solidFill>
                 <a:latin typeface="Montserrat"/>
               </a:rPr>
-              <a:t>da Costa DW, et al. Same-admission versus delayed cholecystectomy for mild gallstone pancreatitis (PONCHO). Lancet. 2015;386(10000):1261-1268.</a:t>
+              <a:t>Tenner S, et al. American College of Gastroenterology Guideline: Management of Acute Pancreatitis. Am J Gastroenterol. 2024;119(3):419-437.</a:t>
             </a:r>
           </a:p>
         </p:txBody>
@@ -6385,7 +6385,7 @@
         </p:nvSpPr>
         <p:spPr>
           <a:xfrm>
-            <a:off x="6217920" y="1874519"/>
+            <a:off x="594360" y="4398264"/>
             <a:ext cx="411480" cy="320040"/>
           </a:xfrm>
           <a:prstGeom prst="rect">
@@ -6427,7 +6427,7 @@
         </p:nvSpPr>
         <p:spPr>
           <a:xfrm>
-            <a:off x="6675120" y="1874519"/>
+            <a:off x="1051560" y="4398264"/>
             <a:ext cx="4892040" cy="749808"/>
           </a:xfrm>
           <a:prstGeom prst="rect">
@@ -6456,7 +6456,7 @@
                 </a:solidFill>
                 <a:latin typeface="Montserrat"/>
               </a:rPr>
-              <a:t>Kumar V, Abbas AK, Aster JC. Robbins y Cotran: Patología Estructural y Funcional. 10.ª ed. Elsevier; 2021.</a:t>
+              <a:t>da Costa DW, et al. Same-admission versus delayed cholecystectomy for mild gallstone pancreatitis (PONCHO). Lancet. 2015;386(10000):1261-1268.</a:t>
             </a:r>
           </a:p>
         </p:txBody>
@@ -6469,7 +6469,7 @@
         </p:nvSpPr>
         <p:spPr>
           <a:xfrm>
-            <a:off x="6217920" y="2715768"/>
+            <a:off x="6217920" y="1874519"/>
             <a:ext cx="411480" cy="320040"/>
           </a:xfrm>
           <a:prstGeom prst="rect">
@@ -6511,7 +6511,7 @@
         </p:nvSpPr>
         <p:spPr>
           <a:xfrm>
-            <a:off x="6675120" y="2715768"/>
+            <a:off x="6675120" y="1874519"/>
             <a:ext cx="4892040" cy="749808"/>
           </a:xfrm>
           <a:prstGeom prst="rect">
@@ -6540,7 +6540,7 @@
                 </a:solidFill>
                 <a:latin typeface="Montserrat"/>
               </a:rPr>
-              <a:t>Brunton LL, Hilal-Dandan R, Knollmann BC. Goodman &amp; Gilman: Las Bases Farmacológicas de la Terapéutica. 13.ª ed. McGraw-Hill; 2019.</a:t>
+              <a:t>Kumar V, Abbas AK, Aster JC. Robbins y Cotran: Patología Estructural y Funcional. 10.ª ed. Elsevier; 2021.</a:t>
             </a:r>
           </a:p>
         </p:txBody>
@@ -6553,7 +6553,7 @@
         </p:nvSpPr>
         <p:spPr>
           <a:xfrm>
-            <a:off x="6217920" y="3557015"/>
+            <a:off x="6217920" y="2715768"/>
             <a:ext cx="411480" cy="320040"/>
           </a:xfrm>
           <a:prstGeom prst="rect">
@@ -6595,7 +6595,7 @@
         </p:nvSpPr>
         <p:spPr>
           <a:xfrm>
-            <a:off x="6675120" y="3557015"/>
+            <a:off x="6675120" y="2715768"/>
             <a:ext cx="4892040" cy="749808"/>
           </a:xfrm>
           <a:prstGeom prst="rect">
@@ -6624,6 +6624,90 @@
                 </a:solidFill>
                 <a:latin typeface="Montserrat"/>
               </a:rPr>
+              <a:t>Brunton LL, Hilal-Dandan R, Knollmann BC. Goodman &amp; Gilman: Las Bases Farmacológicas de la Terapéutica. 13.ª ed. McGraw-Hill; 2019.</a:t>
+            </a:r>
+          </a:p>
+        </p:txBody>
+      </p:sp>
+      <p:sp>
+        <p:nvSpPr>
+          <p:cNvPr id="22" name="TextBox 21"/>
+          <p:cNvSpPr txBox="1"/>
+          <p:nvPr/>
+        </p:nvSpPr>
+        <p:spPr>
+          <a:xfrm>
+            <a:off x="6217920" y="3557015"/>
+            <a:ext cx="411480" cy="320040"/>
+          </a:xfrm>
+          <a:prstGeom prst="rect">
+            <a:avLst/>
+          </a:prstGeom>
+          <a:noFill/>
+        </p:spPr>
+        <p:txBody>
+          <a:bodyPr wrap="square" anchor="t" lIns="0" rIns="0" tIns="0" bIns="0">
+            <a:spAutoFit/>
+          </a:bodyPr>
+          <a:lstStyle/>
+          <a:p>
+            <a:pPr algn="l">
+              <a:lnSpc>
+                <a:spcPct val="108000"/>
+              </a:lnSpc>
+              <a:spcAft>
+                <a:spcPts val="300"/>
+              </a:spcAft>
+            </a:pPr>
+            <a:r>
+              <a:rPr sz="1200" b="1" i="0">
+                <a:solidFill>
+                  <a:srgbClr val="CA2728"/>
+                </a:solidFill>
+                <a:latin typeface="Montserrat"/>
+              </a:rPr>
+              <a:t>7.</a:t>
+            </a:r>
+          </a:p>
+        </p:txBody>
+      </p:sp>
+      <p:sp>
+        <p:nvSpPr>
+          <p:cNvPr id="23" name="TextBox 22"/>
+          <p:cNvSpPr txBox="1"/>
+          <p:nvPr/>
+        </p:nvSpPr>
+        <p:spPr>
+          <a:xfrm>
+            <a:off x="6675120" y="3557015"/>
+            <a:ext cx="4892040" cy="749808"/>
+          </a:xfrm>
+          <a:prstGeom prst="rect">
+            <a:avLst/>
+          </a:prstGeom>
+          <a:noFill/>
+        </p:spPr>
+        <p:txBody>
+          <a:bodyPr wrap="square" anchor="t" lIns="0" rIns="0" tIns="0" bIns="0">
+            <a:spAutoFit/>
+          </a:bodyPr>
+          <a:lstStyle/>
+          <a:p>
+            <a:pPr algn="l">
+              <a:lnSpc>
+                <a:spcPct val="110000"/>
+              </a:lnSpc>
+              <a:spcAft>
+                <a:spcPts val="300"/>
+              </a:spcAft>
+            </a:pPr>
+            <a:r>
+              <a:rPr sz="1050" b="0" i="0">
+                <a:solidFill>
+                  <a:srgbClr val="2B2C4A"/>
+                </a:solidFill>
+                <a:latin typeface="Montserrat"/>
+              </a:rPr>
               <a:t>Argente HA, Álvarez ME. Semiología Médica: Fisiopatología, Semiotecnia y Propedéutica. 3.ª ed. Médica Panamericana; 2021.</a:t>
             </a:r>
           </a:p>
@@ -6631,7 +6715,7 @@
       </p:sp>
       <p:sp>
         <p:nvSpPr>
-          <p:cNvPr id="22" name="TextBox 21"/>
+          <p:cNvPr id="24" name="TextBox 23"/>
           <p:cNvSpPr txBox="1"/>
           <p:nvPr/>
         </p:nvSpPr>
@@ -16028,7 +16112,7 @@
                 </a:solidFill>
                 <a:latin typeface="Montserrat"/>
               </a:rPr>
-              <a:t>CONCLUSIÓN EDITORIAL:  La TC a las 72–96 h evita subestimar la necrosis; en este caso la forma es edematosa.</a:t>
+              <a:t>CONCLUSIÓN EDITORIAL:  La TC a las 72–96 h reduce el riesgo de subestimar la necrosis; en este caso la forma es edematosa.</a:t>
             </a:r>
           </a:p>
         </p:txBody>

</xml_diff>